<commit_message>
docs: Update forward status transition specifications for Draft->Proposal->Confirmed->InProgress->Completed
</commit_message>
<xml_diff>
--- a/UserManuals/Uno_Tour_Status_Transition_Process_Flows.pptx
+++ b/UserManuals/Uno_Tour_Status_Transition_Process_Flows.pptx
@@ -10,6 +10,8 @@
     <p:sldId id="258" r:id="rId9"/>
     <p:sldId id="259" r:id="rId10"/>
     <p:sldId id="260" r:id="rId11"/>
+    <p:sldId id="261" r:id="rId12"/>
+    <p:sldId id="262" r:id="rId13"/>
   </p:sldIdLst>
   <p:sldSz cx="12191695" cy="6858000" type="screen4x3"/>
   <p:notesSz cx="6858000" cy="9144000"/>
@@ -3165,7 +3167,7 @@
               </a:defRPr>
             </a:pPr>
             <a:r>
-              <a:t>UNO_ERP Tour Status Transition Criteria &amp; Checkpoints</a:t>
+              <a:t>UNO_ERP Tour Status Transition Process Flows</a:t>
             </a:r>
           </a:p>
           <a:p>
@@ -3180,7 +3182,7 @@
               </a:defRPr>
             </a:pPr>
             <a:r>
-              <a:t>Process Lifecycle Definition, Checkpoint Gates, and Automated Warning System</a:t>
+              <a:t>Detailed Forward Transition Criteria: Draft ➔ Proposal ➔ Confirmed ➔ In Progress ➔ Completed</a:t>
             </a:r>
           </a:p>
           <a:p>
@@ -3195,7 +3197,7 @@
               </a:defRPr>
             </a:pPr>
             <a:r>
-              <a:t>Action 1 Process Specification Document | August 2026</a:t>
+              <a:t>Action 1 Forward Transition Criteria Specification | August 2026</a:t>
             </a:r>
           </a:p>
         </p:txBody>
@@ -3270,7 +3272,7 @@
         <p:spPr>
           <a:xfrm>
             <a:off x="548640" y="137160"/>
-            <a:ext cx="9144000" cy="731520"/>
+            <a:ext cx="8686800" cy="731520"/>
           </a:xfrm>
           <a:prstGeom prst="rect">
             <a:avLst/>
@@ -3291,7 +3293,7 @@
               </a:defRPr>
             </a:pPr>
             <a:r>
-              <a:t>Tour Lifecycle Status Transition Architecture</a:t>
+              <a:t>Transition Gate 1: Draft ➔ Proposal</a:t>
             </a:r>
           </a:p>
         </p:txBody>
@@ -3304,8 +3306,8 @@
         </p:nvSpPr>
         <p:spPr>
           <a:xfrm>
-            <a:off x="9326880" y="274320"/>
-            <a:ext cx="2286000" cy="411480"/>
+            <a:off x="9144000" y="274320"/>
+            <a:ext cx="2468880" cy="411480"/>
           </a:xfrm>
           <a:prstGeom prst="roundRect">
             <a:avLst/>
@@ -3343,7 +3345,7 @@
               </a:defRPr>
             </a:pPr>
             <a:r>
-              <a:t>PROCESS FLOW</a:t>
+              <a:t>GATE 1 (ORDER 1➔2)</a:t>
             </a:r>
           </a:p>
         </p:txBody>
@@ -3356,18 +3358,18 @@
         </p:nvSpPr>
         <p:spPr>
           <a:xfrm>
-            <a:off x="548640" y="1371600"/>
-            <a:ext cx="3566160" cy="2194560"/>
+            <a:off x="548640" y="1280160"/>
+            <a:ext cx="3840480" cy="5120640"/>
           </a:xfrm>
           <a:prstGeom prst="roundRect">
             <a:avLst/>
           </a:prstGeom>
           <a:solidFill>
-            <a:srgbClr val="FFFFFF"/>
+            <a:srgbClr val="F8FAFC"/>
           </a:solidFill>
           <a:ln w="25400">
             <a:solidFill>
-              <a:srgbClr val="64748B"/>
+              <a:srgbClr val="F59E0B"/>
             </a:solidFill>
           </a:ln>
         </p:spPr>
@@ -3390,53 +3392,208 @@
           <a:lstStyle/>
           <a:p>
             <a:pPr algn="ctr">
-              <a:defRPr sz="1600" b="1">
-                <a:solidFill>
-                  <a:srgbClr val="1E293B"/>
-                </a:solidFill>
-              </a:defRPr>
-            </a:pPr>
-            <a:r>
-              <a:t>1. Draft</a:t>
+              <a:defRPr sz="1200" b="1">
+                <a:solidFill>
+                  <a:srgbClr val="64748B"/>
+                </a:solidFill>
+              </a:defRPr>
+            </a:pPr>
+            <a:r>
+              <a:t>FORWARD TRANSITION</a:t>
             </a:r>
           </a:p>
           <a:p>
             <a:pPr>
               <a:spcBef>
-                <a:spcPts val="800"/>
+                <a:spcPts val="600"/>
               </a:spcBef>
-              <a:defRPr sz="1200">
+              <a:defRPr sz="1800" b="1">
+                <a:solidFill>
+                  <a:srgbClr val="F59E0B"/>
+                </a:solidFill>
+              </a:defRPr>
+            </a:pPr>
+            <a:r>
+              <a:t>Draft  ➔  Proposal</a:t>
+            </a:r>
+          </a:p>
+          <a:p>
+            <a:pPr>
+              <a:spcBef>
+                <a:spcPts val="1600"/>
+              </a:spcBef>
+              <a:defRPr sz="1300" b="1">
+                <a:solidFill>
+                  <a:srgbClr val="1E293B"/>
+                </a:solidFill>
+              </a:defRPr>
+            </a:pPr>
+            <a:r>
+              <a:t>Business Meaning &amp; Impact:</a:t>
+            </a:r>
+          </a:p>
+          <a:p>
+            <a:pPr>
+              <a:spcBef>
+                <a:spcPts val="600"/>
+              </a:spcBef>
+              <a:defRPr sz="1100">
                 <a:solidFill>
                   <a:srgbClr val="64748B"/>
                 </a:solidFill>
               </a:defRPr>
             </a:pPr>
             <a:r>
-              <a:t>Initial itinerary assembly, estimated pax count, draft pricing.</a:t>
-            </a:r>
-          </a:p>
-        </p:txBody>
-      </p:sp>
-      <p:sp>
-        <p:nvSpPr>
-          <p:cNvPr id="6" name="Rounded Rectangle 5"/>
+              <a:t>Freezes the initial tour itinerary quote so sales team can issue formal B2B proposal quotes to clients.</a:t>
+            </a:r>
+          </a:p>
+          <a:p>
+            <a:pPr>
+              <a:spcBef>
+                <a:spcPts val="1600"/>
+              </a:spcBef>
+              <a:defRPr sz="1300" b="1">
+                <a:solidFill>
+                  <a:srgbClr val="1E293B"/>
+                </a:solidFill>
+              </a:defRPr>
+            </a:pPr>
+            <a:r>
+              <a:t>Automated System Checks:</a:t>
+            </a:r>
+          </a:p>
+          <a:p>
+            <a:pPr>
+              <a:spcBef>
+                <a:spcPts val="400"/>
+              </a:spcBef>
+              <a:defRPr sz="1100">
+                <a:solidFill>
+                  <a:srgbClr val="F59E0B"/>
+                </a:solidFill>
+              </a:defRPr>
+            </a:pPr>
+            <a:r>
+              <a:t>• ProjectId != null</a:t>
+            </a:r>
+          </a:p>
+          <a:p>
+            <a:pPr>
+              <a:spcBef>
+                <a:spcPts val="400"/>
+              </a:spcBef>
+              <a:defRPr sz="1100">
+                <a:solidFill>
+                  <a:srgbClr val="F59E0B"/>
+                </a:solidFill>
+              </a:defRPr>
+            </a:pPr>
+            <a:r>
+              <a:t>• ArrivalDate != default</a:t>
+            </a:r>
+          </a:p>
+          <a:p>
+            <a:pPr>
+              <a:spcBef>
+                <a:spcPts val="400"/>
+              </a:spcBef>
+              <a:defRPr sz="1100">
+                <a:solidFill>
+                  <a:srgbClr val="F59E0B"/>
+                </a:solidFill>
+              </a:defRPr>
+            </a:pPr>
+            <a:r>
+              <a:t>• EndDate &gt; ArrivalDate</a:t>
+            </a:r>
+          </a:p>
+          <a:p>
+            <a:pPr>
+              <a:spcBef>
+                <a:spcPts val="400"/>
+              </a:spcBef>
+              <a:defRPr sz="1100">
+                <a:solidFill>
+                  <a:srgbClr val="F59E0B"/>
+                </a:solidFill>
+              </a:defRPr>
+            </a:pPr>
+            <a:r>
+              <a:t>• Pax &gt; 0</a:t>
+            </a:r>
+          </a:p>
+          <a:p>
+            <a:pPr>
+              <a:spcBef>
+                <a:spcPts val="400"/>
+              </a:spcBef>
+              <a:defRPr sz="1100">
+                <a:solidFill>
+                  <a:srgbClr val="F59E0B"/>
+                </a:solidFill>
+              </a:defRPr>
+            </a:pPr>
+            <a:r>
+              <a:t>• BaseFee &gt; 0</a:t>
+            </a:r>
+          </a:p>
+        </p:txBody>
+      </p:sp>
+      <p:sp>
+        <p:nvSpPr>
+          <p:cNvPr id="6" name="TextBox 5"/>
+          <p:cNvSpPr txBox="1"/>
+          <p:nvPr/>
+        </p:nvSpPr>
+        <p:spPr>
+          <a:xfrm>
+            <a:off x="4572000" y="1188720"/>
+            <a:ext cx="7040880" cy="5212080"/>
+          </a:xfrm>
+          <a:prstGeom prst="rect">
+            <a:avLst/>
+          </a:prstGeom>
+          <a:noFill/>
+        </p:spPr>
+        <p:txBody>
+          <a:bodyPr wrap="square">
+            <a:spAutoFit/>
+          </a:bodyPr>
+          <a:lstStyle/>
+          <a:p>
+            <a:pPr>
+              <a:defRPr sz="1500" b="1">
+                <a:solidFill>
+                  <a:srgbClr val="1E293B"/>
+                </a:solidFill>
+              </a:defRPr>
+            </a:pPr>
+            <a:r>
+              <a:t>Mandatory Transition Checkpoints (100% Pass Required):</a:t>
+            </a:r>
+          </a:p>
+        </p:txBody>
+      </p:sp>
+      <p:sp>
+        <p:nvSpPr>
+          <p:cNvPr id="7" name="Rounded Rectangle 6"/>
           <p:cNvSpPr/>
           <p:nvPr/>
         </p:nvSpPr>
         <p:spPr>
           <a:xfrm>
-            <a:off x="4297679" y="1371600"/>
-            <a:ext cx="3566160" cy="2194560"/>
+            <a:off x="4572000" y="1737360"/>
+            <a:ext cx="7040880" cy="1051560"/>
           </a:xfrm>
           <a:prstGeom prst="roundRect">
             <a:avLst/>
           </a:prstGeom>
           <a:solidFill>
-            <a:srgbClr val="F59E0B"/>
-          </a:solidFill>
-          <a:ln w="25400">
+            <a:srgbClr val="FFFFFF"/>
+          </a:solidFill>
+          <a:ln w="19050">
             <a:solidFill>
-              <a:srgbClr val="F59E0B"/>
+              <a:srgbClr val="E2E8F0"/>
             </a:solidFill>
           </a:ln>
         </p:spPr>
@@ -3459,54 +3616,52 @@
           <a:lstStyle/>
           <a:p>
             <a:pPr algn="ctr">
-              <a:defRPr sz="1600" b="1">
-                <a:solidFill>
-                  <a:srgbClr val="FFFFFF"/>
-                </a:solidFill>
-              </a:defRPr>
-            </a:pPr>
-            <a:r>
-              <a:t>2. Proposal</a:t>
+              <a:defRPr sz="1300" b="1">
+                <a:solidFill>
+                  <a:srgbClr val="F59E0B"/>
+                </a:solidFill>
+              </a:defRPr>
+            </a:pPr>
+            <a:r>
+              <a:t>Checkpoint 1: Project &amp; Destination Definition</a:t>
             </a:r>
           </a:p>
           <a:p>
             <a:pPr>
               <a:spcBef>
-                <a:spcPts val="800"/>
+                <a:spcPts val="400"/>
               </a:spcBef>
-              <a:defRPr sz="1200">
-                <a:solidFill>
-                  <a:srgbClr val="FFFFFF"/>
-                </a:solidFill>
-              </a:defRPr>
-            </a:pPr>
-            <a:r>
-              <a:t>Client proposal sent, base services loaded, pricing locked.</a:t>
-            </a:r>
-          </a:p>
-        </p:txBody>
-      </p:sp>
-      <p:sp>
-        <p:nvSpPr>
-          <p:cNvPr id="7" name="Rounded Rectangle 6"/>
+              <a:defRPr sz="1100">
+                <a:solidFill>
+                  <a:srgbClr val="1E293B"/>
+                </a:solidFill>
+              </a:defRPr>
+            </a:pPr>
+            <a:r>
+              <a:t>Valid B2B Project Code assigned (e.g. Orta Avrupa - BVP) and destination city routing selected.</a:t>
+            </a:r>
+          </a:p>
+        </p:txBody>
+      </p:sp>
+      <p:sp>
+        <p:nvSpPr>
+          <p:cNvPr id="8" name="Rectangle 7"/>
           <p:cNvSpPr/>
           <p:nvPr/>
         </p:nvSpPr>
         <p:spPr>
           <a:xfrm>
-            <a:off x="8046719" y="1371600"/>
-            <a:ext cx="3566160" cy="2194560"/>
-          </a:xfrm>
-          <a:prstGeom prst="roundRect">
+            <a:off x="4572000" y="1737360"/>
+            <a:ext cx="137160" cy="1051560"/>
+          </a:xfrm>
+          <a:prstGeom prst="rect">
             <a:avLst/>
           </a:prstGeom>
           <a:solidFill>
-            <a:srgbClr val="2563EB"/>
-          </a:solidFill>
-          <a:ln w="25400">
-            <a:solidFill>
-              <a:srgbClr val="2563EB"/>
-            </a:solidFill>
+            <a:srgbClr val="F59E0B"/>
+          </a:solidFill>
+          <a:ln>
+            <a:noFill/>
           </a:ln>
         </p:spPr>
         <p:style>
@@ -3524,57 +3679,33 @@
           </a:fontRef>
         </p:style>
         <p:txBody>
-          <a:bodyPr rtlCol="0" anchor="ctr" wrap="square"/>
-          <a:lstStyle/>
-          <a:p>
-            <a:pPr algn="ctr">
-              <a:defRPr sz="1600" b="1">
-                <a:solidFill>
-                  <a:srgbClr val="FFFFFF"/>
-                </a:solidFill>
-              </a:defRPr>
-            </a:pPr>
-            <a:r>
-              <a:t>3. Confirmed</a:t>
-            </a:r>
-          </a:p>
-          <a:p>
-            <a:pPr>
-              <a:spcBef>
-                <a:spcPts val="800"/>
-              </a:spcBef>
-              <a:defRPr sz="1200">
-                <a:solidFill>
-                  <a:srgbClr val="FFFFFF"/>
-                </a:solidFill>
-              </a:defRPr>
-            </a:pPr>
-            <a:r>
-              <a:t>All 4 Checkpoints mandatory: Hotel, Guide, Bus, Client Deposit.</a:t>
-            </a:r>
-          </a:p>
-        </p:txBody>
-      </p:sp>
-      <p:sp>
-        <p:nvSpPr>
-          <p:cNvPr id="8" name="Rounded Rectangle 7"/>
+          <a:bodyPr rtlCol="0" anchor="ctr"/>
+          <a:lstStyle/>
+          <a:p>
+            <a:pPr algn="ctr"/>
+          </a:p>
+        </p:txBody>
+      </p:sp>
+      <p:sp>
+        <p:nvSpPr>
+          <p:cNvPr id="9" name="Rounded Rectangle 8"/>
           <p:cNvSpPr/>
           <p:nvPr/>
         </p:nvSpPr>
         <p:spPr>
           <a:xfrm>
-            <a:off x="548640" y="3840480"/>
-            <a:ext cx="3566160" cy="2194560"/>
+            <a:off x="4572000" y="2926080"/>
+            <a:ext cx="7040880" cy="1051560"/>
           </a:xfrm>
           <a:prstGeom prst="roundRect">
             <a:avLst/>
           </a:prstGeom>
           <a:solidFill>
-            <a:srgbClr val="7C3AED"/>
-          </a:solidFill>
-          <a:ln w="25400">
+            <a:srgbClr val="FFFFFF"/>
+          </a:solidFill>
+          <a:ln w="19050">
             <a:solidFill>
-              <a:srgbClr val="7C3AED"/>
+              <a:srgbClr val="E2E8F0"/>
             </a:solidFill>
           </a:ln>
         </p:spPr>
@@ -3597,54 +3728,52 @@
           <a:lstStyle/>
           <a:p>
             <a:pPr algn="ctr">
-              <a:defRPr sz="1600" b="1">
-                <a:solidFill>
-                  <a:srgbClr val="FFFFFF"/>
-                </a:solidFill>
-              </a:defRPr>
-            </a:pPr>
-            <a:r>
-              <a:t>4. In Progress</a:t>
+              <a:defRPr sz="1300" b="1">
+                <a:solidFill>
+                  <a:srgbClr val="F59E0B"/>
+                </a:solidFill>
+              </a:defRPr>
+            </a:pPr>
+            <a:r>
+              <a:t>Checkpoint 2: Pax Breakdown &amp; Pricing Engine</a:t>
             </a:r>
           </a:p>
           <a:p>
             <a:pPr>
               <a:spcBef>
-                <a:spcPts val="800"/>
+                <a:spcPts val="400"/>
               </a:spcBef>
-              <a:defRPr sz="1200">
-                <a:solidFill>
-                  <a:srgbClr val="FFFFFF"/>
-                </a:solidFill>
-              </a:defRPr>
-            </a:pPr>
-            <a:r>
-              <a:t>Arrival date reached, flight landed, active tour execution.</a:t>
-            </a:r>
-          </a:p>
-        </p:txBody>
-      </p:sp>
-      <p:sp>
-        <p:nvSpPr>
-          <p:cNvPr id="9" name="Rounded Rectangle 8"/>
+              <a:defRPr sz="1100">
+                <a:solidFill>
+                  <a:srgbClr val="1E293B"/>
+                </a:solidFill>
+              </a:defRPr>
+            </a:pPr>
+            <a:r>
+              <a:t>Passenger count entered (Adults, Children, Infants). Package rates &amp; base fee calculated (BaseFee &gt; €0).</a:t>
+            </a:r>
+          </a:p>
+        </p:txBody>
+      </p:sp>
+      <p:sp>
+        <p:nvSpPr>
+          <p:cNvPr id="10" name="Rectangle 9"/>
           <p:cNvSpPr/>
           <p:nvPr/>
         </p:nvSpPr>
         <p:spPr>
           <a:xfrm>
-            <a:off x="4297679" y="3840480"/>
-            <a:ext cx="3566160" cy="2194560"/>
-          </a:xfrm>
-          <a:prstGeom prst="roundRect">
+            <a:off x="4572000" y="2926080"/>
+            <a:ext cx="137160" cy="1051560"/>
+          </a:xfrm>
+          <a:prstGeom prst="rect">
             <a:avLst/>
           </a:prstGeom>
           <a:solidFill>
-            <a:srgbClr val="10B981"/>
-          </a:solidFill>
-          <a:ln w="25400">
-            <a:solidFill>
-              <a:srgbClr val="10B981"/>
-            </a:solidFill>
+            <a:srgbClr val="F59E0B"/>
+          </a:solidFill>
+          <a:ln>
+            <a:noFill/>
           </a:ln>
         </p:spPr>
         <p:style>
@@ -3662,57 +3791,33 @@
           </a:fontRef>
         </p:style>
         <p:txBody>
-          <a:bodyPr rtlCol="0" anchor="ctr" wrap="square"/>
-          <a:lstStyle/>
-          <a:p>
-            <a:pPr algn="ctr">
-              <a:defRPr sz="1600" b="1">
-                <a:solidFill>
-                  <a:srgbClr val="FFFFFF"/>
-                </a:solidFill>
-              </a:defRPr>
-            </a:pPr>
-            <a:r>
-              <a:t>5. Completed</a:t>
-            </a:r>
-          </a:p>
-          <a:p>
-            <a:pPr>
-              <a:spcBef>
-                <a:spcPts val="800"/>
-              </a:spcBef>
-              <a:defRPr sz="1200">
-                <a:solidFill>
-                  <a:srgbClr val="FFFFFF"/>
-                </a:solidFill>
-              </a:defRPr>
-            </a:pPr>
-            <a:r>
-              <a:t>Return date reached, 100% costs/sales entered, Accounting Closed.</a:t>
-            </a:r>
-          </a:p>
-        </p:txBody>
-      </p:sp>
-      <p:sp>
-        <p:nvSpPr>
-          <p:cNvPr id="10" name="Rounded Rectangle 9"/>
+          <a:bodyPr rtlCol="0" anchor="ctr"/>
+          <a:lstStyle/>
+          <a:p>
+            <a:pPr algn="ctr"/>
+          </a:p>
+        </p:txBody>
+      </p:sp>
+      <p:sp>
+        <p:nvSpPr>
+          <p:cNvPr id="11" name="Rounded Rectangle 10"/>
           <p:cNvSpPr/>
           <p:nvPr/>
         </p:nvSpPr>
         <p:spPr>
           <a:xfrm>
-            <a:off x="8046719" y="3840480"/>
-            <a:ext cx="3566160" cy="2194560"/>
+            <a:off x="4572000" y="4114800"/>
+            <a:ext cx="7040880" cy="1051560"/>
           </a:xfrm>
           <a:prstGeom prst="roundRect">
             <a:avLst/>
           </a:prstGeom>
           <a:solidFill>
-            <a:srgbClr val="F43F5E"/>
-          </a:solidFill>
-          <a:ln w="25400">
+            <a:srgbClr val="FFFFFF"/>
+          </a:solidFill>
+          <a:ln w="19050">
             <a:solidFill>
-              <a:srgbClr val="F43F5E"/>
+              <a:srgbClr val="E2E8F0"/>
             </a:solidFill>
           </a:ln>
         </p:spPr>
@@ -3735,30 +3840,185 @@
           <a:lstStyle/>
           <a:p>
             <a:pPr algn="ctr">
-              <a:defRPr sz="1600" b="1">
-                <a:solidFill>
-                  <a:srgbClr val="FFFFFF"/>
-                </a:solidFill>
-              </a:defRPr>
-            </a:pPr>
-            <a:r>
-              <a:t>6. Cancelled</a:t>
+              <a:defRPr sz="1300" b="1">
+                <a:solidFill>
+                  <a:srgbClr val="F59E0B"/>
+                </a:solidFill>
+              </a:defRPr>
+            </a:pPr>
+            <a:r>
+              <a:t>Checkpoint 3: Itinerary Date Boundaries</a:t>
             </a:r>
           </a:p>
           <a:p>
             <a:pPr>
               <a:spcBef>
-                <a:spcPts val="800"/>
+                <a:spcPts val="400"/>
               </a:spcBef>
-              <a:defRPr sz="1200">
-                <a:solidFill>
-                  <a:srgbClr val="FFFFFF"/>
-                </a:solidFill>
-              </a:defRPr>
-            </a:pPr>
-            <a:r>
-              <a:t>Cancellation logged, supplier fees &amp; refund adjustments settled.</a:t>
-            </a:r>
+              <a:defRPr sz="1100">
+                <a:solidFill>
+                  <a:srgbClr val="1E293B"/>
+                </a:solidFill>
+              </a:defRPr>
+            </a:pPr>
+            <a:r>
+              <a:t>Arrival Date and End Date defined with valid non-zero duration (EndDate &gt; ArrivalDate).</a:t>
+            </a:r>
+          </a:p>
+        </p:txBody>
+      </p:sp>
+      <p:sp>
+        <p:nvSpPr>
+          <p:cNvPr id="12" name="Rectangle 11"/>
+          <p:cNvSpPr/>
+          <p:nvPr/>
+        </p:nvSpPr>
+        <p:spPr>
+          <a:xfrm>
+            <a:off x="4572000" y="4114800"/>
+            <a:ext cx="137160" cy="1051560"/>
+          </a:xfrm>
+          <a:prstGeom prst="rect">
+            <a:avLst/>
+          </a:prstGeom>
+          <a:solidFill>
+            <a:srgbClr val="F59E0B"/>
+          </a:solidFill>
+          <a:ln>
+            <a:noFill/>
+          </a:ln>
+        </p:spPr>
+        <p:style>
+          <a:lnRef idx="1">
+            <a:schemeClr val="accent1"/>
+          </a:lnRef>
+          <a:fillRef idx="3">
+            <a:schemeClr val="accent1"/>
+          </a:fillRef>
+          <a:effectRef idx="2">
+            <a:schemeClr val="accent1"/>
+          </a:effectRef>
+          <a:fontRef idx="minor">
+            <a:schemeClr val="lt1"/>
+          </a:fontRef>
+        </p:style>
+        <p:txBody>
+          <a:bodyPr rtlCol="0" anchor="ctr"/>
+          <a:lstStyle/>
+          <a:p>
+            <a:pPr algn="ctr"/>
+          </a:p>
+        </p:txBody>
+      </p:sp>
+      <p:sp>
+        <p:nvSpPr>
+          <p:cNvPr id="13" name="Rounded Rectangle 12"/>
+          <p:cNvSpPr/>
+          <p:nvPr/>
+        </p:nvSpPr>
+        <p:spPr>
+          <a:xfrm>
+            <a:off x="4572000" y="5303520"/>
+            <a:ext cx="7040880" cy="1051560"/>
+          </a:xfrm>
+          <a:prstGeom prst="roundRect">
+            <a:avLst/>
+          </a:prstGeom>
+          <a:solidFill>
+            <a:srgbClr val="FFFFFF"/>
+          </a:solidFill>
+          <a:ln w="19050">
+            <a:solidFill>
+              <a:srgbClr val="E2E8F0"/>
+            </a:solidFill>
+          </a:ln>
+        </p:spPr>
+        <p:style>
+          <a:lnRef idx="1">
+            <a:schemeClr val="accent1"/>
+          </a:lnRef>
+          <a:fillRef idx="3">
+            <a:schemeClr val="accent1"/>
+          </a:fillRef>
+          <a:effectRef idx="2">
+            <a:schemeClr val="accent1"/>
+          </a:effectRef>
+          <a:fontRef idx="minor">
+            <a:schemeClr val="lt1"/>
+          </a:fontRef>
+        </p:style>
+        <p:txBody>
+          <a:bodyPr rtlCol="0" anchor="ctr" wrap="square"/>
+          <a:lstStyle/>
+          <a:p>
+            <a:pPr algn="ctr">
+              <a:defRPr sz="1300" b="1">
+                <a:solidFill>
+                  <a:srgbClr val="F59E0B"/>
+                </a:solidFill>
+              </a:defRPr>
+            </a:pPr>
+            <a:r>
+              <a:t>Checkpoint 4: Initial Service Skeleton</a:t>
+            </a:r>
+          </a:p>
+          <a:p>
+            <a:pPr>
+              <a:spcBef>
+                <a:spcPts val="400"/>
+              </a:spcBef>
+              <a:defRPr sz="1100">
+                <a:solidFill>
+                  <a:srgbClr val="1E293B"/>
+                </a:solidFill>
+              </a:defRPr>
+            </a:pPr>
+            <a:r>
+              <a:t>Base hotel, transport, and guide service templates instantiated in tour record.</a:t>
+            </a:r>
+          </a:p>
+        </p:txBody>
+      </p:sp>
+      <p:sp>
+        <p:nvSpPr>
+          <p:cNvPr id="14" name="Rectangle 13"/>
+          <p:cNvSpPr/>
+          <p:nvPr/>
+        </p:nvSpPr>
+        <p:spPr>
+          <a:xfrm>
+            <a:off x="4572000" y="5303520"/>
+            <a:ext cx="137160" cy="1051560"/>
+          </a:xfrm>
+          <a:prstGeom prst="rect">
+            <a:avLst/>
+          </a:prstGeom>
+          <a:solidFill>
+            <a:srgbClr val="F59E0B"/>
+          </a:solidFill>
+          <a:ln>
+            <a:noFill/>
+          </a:ln>
+        </p:spPr>
+        <p:style>
+          <a:lnRef idx="1">
+            <a:schemeClr val="accent1"/>
+          </a:lnRef>
+          <a:fillRef idx="3">
+            <a:schemeClr val="accent1"/>
+          </a:fillRef>
+          <a:effectRef idx="2">
+            <a:schemeClr val="accent1"/>
+          </a:effectRef>
+          <a:fontRef idx="minor">
+            <a:schemeClr val="lt1"/>
+          </a:fontRef>
+        </p:style>
+        <p:txBody>
+          <a:bodyPr rtlCol="0" anchor="ctr"/>
+          <a:lstStyle/>
+          <a:p>
+            <a:pPr algn="ctr"/>
           </a:p>
         </p:txBody>
       </p:sp>
@@ -3832,7 +4092,7 @@
         <p:spPr>
           <a:xfrm>
             <a:off x="548640" y="137160"/>
-            <a:ext cx="9144000" cy="731520"/>
+            <a:ext cx="8686800" cy="731520"/>
           </a:xfrm>
           <a:prstGeom prst="rect">
             <a:avLst/>
@@ -3853,7 +4113,7 @@
               </a:defRPr>
             </a:pPr>
             <a:r>
-              <a:t>Transition Gate: Proposal -&gt; Confirmed</a:t>
+              <a:t>Transition Gate 2: Proposal ➔ Confirmed</a:t>
             </a:r>
           </a:p>
         </p:txBody>
@@ -3866,8 +4126,8 @@
         </p:nvSpPr>
         <p:spPr>
           <a:xfrm>
-            <a:off x="9326880" y="274320"/>
-            <a:ext cx="2286000" cy="411480"/>
+            <a:off x="9144000" y="274320"/>
+            <a:ext cx="2468880" cy="411480"/>
           </a:xfrm>
           <a:prstGeom prst="roundRect">
             <a:avLst/>
@@ -3905,56 +4165,21 @@
               </a:defRPr>
             </a:pPr>
             <a:r>
-              <a:t>CRITICAL GATES</a:t>
-            </a:r>
-          </a:p>
-        </p:txBody>
-      </p:sp>
-      <p:sp>
-        <p:nvSpPr>
-          <p:cNvPr id="5" name="TextBox 4"/>
-          <p:cNvSpPr txBox="1"/>
-          <p:nvPr/>
-        </p:nvSpPr>
-        <p:spPr>
-          <a:xfrm>
-            <a:off x="548640" y="1188720"/>
-            <a:ext cx="11094415" cy="5303520"/>
-          </a:xfrm>
-          <a:prstGeom prst="rect">
-            <a:avLst/>
-          </a:prstGeom>
-          <a:noFill/>
-        </p:spPr>
-        <p:txBody>
-          <a:bodyPr wrap="square">
-            <a:spAutoFit/>
-          </a:bodyPr>
-          <a:lstStyle/>
-          <a:p>
-            <a:pPr>
-              <a:defRPr sz="1600" b="1">
-                <a:solidFill>
-                  <a:srgbClr val="1E293B"/>
-                </a:solidFill>
-              </a:defRPr>
-            </a:pPr>
-            <a:r>
-              <a:t>To transition a tour status to CONFIRMED, the system evaluates 4 Mandatory Checkpoints:</a:t>
-            </a:r>
-          </a:p>
-        </p:txBody>
-      </p:sp>
-      <p:sp>
-        <p:nvSpPr>
-          <p:cNvPr id="6" name="Rounded Rectangle 5"/>
+              <a:t>GATE 2 (ORDER 2➔3)</a:t>
+            </a:r>
+          </a:p>
+        </p:txBody>
+      </p:sp>
+      <p:sp>
+        <p:nvSpPr>
+          <p:cNvPr id="5" name="Rounded Rectangle 4"/>
           <p:cNvSpPr/>
           <p:nvPr/>
         </p:nvSpPr>
         <p:spPr>
           <a:xfrm>
-            <a:off x="548640" y="1828800"/>
-            <a:ext cx="11094415" cy="1005840"/>
+            <a:off x="548640" y="1280160"/>
+            <a:ext cx="3840480" cy="5120640"/>
           </a:xfrm>
           <a:prstGeom prst="roundRect">
             <a:avLst/>
@@ -3962,7 +4187,7 @@
           <a:solidFill>
             <a:srgbClr val="F8FAFC"/>
           </a:solidFill>
-          <a:ln w="19050">
+          <a:ln w="25400">
             <a:solidFill>
               <a:srgbClr val="2563EB"/>
             </a:solidFill>
@@ -3987,14 +4212,74 @@
           <a:lstStyle/>
           <a:p>
             <a:pPr algn="ctr">
-              <a:defRPr sz="1400" b="1">
+              <a:defRPr sz="1200" b="1">
+                <a:solidFill>
+                  <a:srgbClr val="64748B"/>
+                </a:solidFill>
+              </a:defRPr>
+            </a:pPr>
+            <a:r>
+              <a:t>FORWARD TRANSITION</a:t>
+            </a:r>
+          </a:p>
+          <a:p>
+            <a:pPr>
+              <a:spcBef>
+                <a:spcPts val="600"/>
+              </a:spcBef>
+              <a:defRPr sz="1800" b="1">
                 <a:solidFill>
                   <a:srgbClr val="2563EB"/>
                 </a:solidFill>
               </a:defRPr>
             </a:pPr>
             <a:r>
-              <a:t>1. Hotel Reservation Checkpoint</a:t>
+              <a:t>Proposal  ➔  Confirmed</a:t>
+            </a:r>
+          </a:p>
+          <a:p>
+            <a:pPr>
+              <a:spcBef>
+                <a:spcPts val="1600"/>
+              </a:spcBef>
+              <a:defRPr sz="1300" b="1">
+                <a:solidFill>
+                  <a:srgbClr val="1E293B"/>
+                </a:solidFill>
+              </a:defRPr>
+            </a:pPr>
+            <a:r>
+              <a:t>Business Meaning &amp; Impact:</a:t>
+            </a:r>
+          </a:p>
+          <a:p>
+            <a:pPr>
+              <a:spcBef>
+                <a:spcPts val="600"/>
+              </a:spcBef>
+              <a:defRPr sz="1100">
+                <a:solidFill>
+                  <a:srgbClr val="64748B"/>
+                </a:solidFill>
+              </a:defRPr>
+            </a:pPr>
+            <a:r>
+              <a:t>Guarantees that the tour is 100% operationally locked and fully backed by supplier reservations.</a:t>
+            </a:r>
+          </a:p>
+          <a:p>
+            <a:pPr>
+              <a:spcBef>
+                <a:spcPts val="1600"/>
+              </a:spcBef>
+              <a:defRPr sz="1300" b="1">
+                <a:solidFill>
+                  <a:srgbClr val="1E293B"/>
+                </a:solidFill>
+              </a:defRPr>
+            </a:pPr>
+            <a:r>
+              <a:t>Automated System Checks:</a:t>
             </a:r>
           </a:p>
           <a:p>
@@ -4002,14 +4287,94 @@
               <a:spcBef>
                 <a:spcPts val="400"/>
               </a:spcBef>
-              <a:defRPr sz="1200">
+              <a:defRPr sz="1100">
+                <a:solidFill>
+                  <a:srgbClr val="2563EB"/>
+                </a:solidFill>
+              </a:defRPr>
+            </a:pPr>
+            <a:r>
+              <a:t>• HotelConfirmed == true</a:t>
+            </a:r>
+          </a:p>
+          <a:p>
+            <a:pPr>
+              <a:spcBef>
+                <a:spcPts val="400"/>
+              </a:spcBef>
+              <a:defRPr sz="1100">
+                <a:solidFill>
+                  <a:srgbClr val="2563EB"/>
+                </a:solidFill>
+              </a:defRPr>
+            </a:pPr>
+            <a:r>
+              <a:t>• GuideAssigned == true</a:t>
+            </a:r>
+          </a:p>
+          <a:p>
+            <a:pPr>
+              <a:spcBef>
+                <a:spcPts val="400"/>
+              </a:spcBef>
+              <a:defRPr sz="1100">
+                <a:solidFill>
+                  <a:srgbClr val="2563EB"/>
+                </a:solidFill>
+              </a:defRPr>
+            </a:pPr>
+            <a:r>
+              <a:t>• TransportConfirmed == true</a:t>
+            </a:r>
+          </a:p>
+          <a:p>
+            <a:pPr>
+              <a:spcBef>
+                <a:spcPts val="400"/>
+              </a:spcBef>
+              <a:defRPr sz="1100">
+                <a:solidFill>
+                  <a:srgbClr val="2563EB"/>
+                </a:solidFill>
+              </a:defRPr>
+            </a:pPr>
+            <a:r>
+              <a:t>• ClientDepositConfirmed == true</a:t>
+            </a:r>
+          </a:p>
+        </p:txBody>
+      </p:sp>
+      <p:sp>
+        <p:nvSpPr>
+          <p:cNvPr id="6" name="TextBox 5"/>
+          <p:cNvSpPr txBox="1"/>
+          <p:nvPr/>
+        </p:nvSpPr>
+        <p:spPr>
+          <a:xfrm>
+            <a:off x="4572000" y="1188720"/>
+            <a:ext cx="7040880" cy="5212080"/>
+          </a:xfrm>
+          <a:prstGeom prst="rect">
+            <a:avLst/>
+          </a:prstGeom>
+          <a:noFill/>
+        </p:spPr>
+        <p:txBody>
+          <a:bodyPr wrap="square">
+            <a:spAutoFit/>
+          </a:bodyPr>
+          <a:lstStyle/>
+          <a:p>
+            <a:pPr>
+              <a:defRPr sz="1500" b="1">
                 <a:solidFill>
                   <a:srgbClr val="1E293B"/>
                 </a:solidFill>
               </a:defRPr>
             </a:pPr>
             <a:r>
-              <a:t>All hotel stays across all cities (Budapest, Vienna, Prague) must have confirmed room bookings &amp; vouchers issued.</a:t>
+              <a:t>Mandatory Transition Checkpoints (100% Pass Required):</a:t>
             </a:r>
           </a:p>
         </p:txBody>
@@ -4022,18 +4387,18 @@
         </p:nvSpPr>
         <p:spPr>
           <a:xfrm>
-            <a:off x="548640" y="2971800"/>
-            <a:ext cx="11094415" cy="1005840"/>
+            <a:off x="4572000" y="1737360"/>
+            <a:ext cx="7040880" cy="1051560"/>
           </a:xfrm>
           <a:prstGeom prst="roundRect">
             <a:avLst/>
           </a:prstGeom>
           <a:solidFill>
-            <a:srgbClr val="F8FAFC"/>
+            <a:srgbClr val="FFFFFF"/>
           </a:solidFill>
           <a:ln w="19050">
             <a:solidFill>
-              <a:srgbClr val="2563EB"/>
+              <a:srgbClr val="E2E8F0"/>
             </a:solidFill>
           </a:ln>
         </p:spPr>
@@ -4056,14 +4421,14 @@
           <a:lstStyle/>
           <a:p>
             <a:pPr algn="ctr">
-              <a:defRPr sz="1400" b="1">
+              <a:defRPr sz="1300" b="1">
                 <a:solidFill>
                   <a:srgbClr val="2563EB"/>
                 </a:solidFill>
               </a:defRPr>
             </a:pPr>
             <a:r>
-              <a:t>2. Guide Assignment Checkpoint</a:t>
+              <a:t>Checkpoint 1: Hotel Reservations Confirmed</a:t>
             </a:r>
           </a:p>
           <a:p>
@@ -4071,39 +4436,37 @@
               <a:spcBef>
                 <a:spcPts val="400"/>
               </a:spcBef>
-              <a:defRPr sz="1200">
+              <a:defRPr sz="1100">
                 <a:solidFill>
                   <a:srgbClr val="1E293B"/>
                 </a:solidFill>
               </a:defRPr>
             </a:pPr>
             <a:r>
-              <a:t>Primary Tour Guide assigned, language verified, daily rate accepted, and contract confirmed.</a:t>
-            </a:r>
-          </a:p>
-        </p:txBody>
-      </p:sp>
-      <p:sp>
-        <p:nvSpPr>
-          <p:cNvPr id="8" name="Rounded Rectangle 7"/>
+              <a:t>100% of city stop hotels (Budapest, Vienna, Prague) have confirmed room reservations &amp; vouchers issued.</a:t>
+            </a:r>
+          </a:p>
+        </p:txBody>
+      </p:sp>
+      <p:sp>
+        <p:nvSpPr>
+          <p:cNvPr id="8" name="Rectangle 7"/>
           <p:cNvSpPr/>
           <p:nvPr/>
         </p:nvSpPr>
         <p:spPr>
           <a:xfrm>
-            <a:off x="548640" y="4114800"/>
-            <a:ext cx="11094415" cy="1005840"/>
-          </a:xfrm>
-          <a:prstGeom prst="roundRect">
+            <a:off x="4572000" y="1737360"/>
+            <a:ext cx="137160" cy="1051560"/>
+          </a:xfrm>
+          <a:prstGeom prst="rect">
             <a:avLst/>
           </a:prstGeom>
           <a:solidFill>
-            <a:srgbClr val="F8FAFC"/>
-          </a:solidFill>
-          <a:ln w="19050">
-            <a:solidFill>
-              <a:srgbClr val="2563EB"/>
-            </a:solidFill>
+            <a:srgbClr val="2563EB"/>
+          </a:solidFill>
+          <a:ln>
+            <a:noFill/>
           </a:ln>
         </p:spPr>
         <p:style>
@@ -4121,34 +4484,10 @@
           </a:fontRef>
         </p:style>
         <p:txBody>
-          <a:bodyPr rtlCol="0" anchor="ctr" wrap="square"/>
-          <a:lstStyle/>
-          <a:p>
-            <a:pPr algn="ctr">
-              <a:defRPr sz="1400" b="1">
-                <a:solidFill>
-                  <a:srgbClr val="2563EB"/>
-                </a:solidFill>
-              </a:defRPr>
-            </a:pPr>
-            <a:r>
-              <a:t>3. Transportation Checkpoint</a:t>
-            </a:r>
-          </a:p>
-          <a:p>
-            <a:pPr>
-              <a:spcBef>
-                <a:spcPts val="400"/>
-              </a:spcBef>
-              <a:defRPr sz="1200">
-                <a:solidFill>
-                  <a:srgbClr val="1E293B"/>
-                </a:solidFill>
-              </a:defRPr>
-            </a:pPr>
-            <a:r>
-              <a:t>Bus / Transport company assigned, coach capacity checked (e.g. 50-seat coach for 36 pax), driver details loaded.</a:t>
-            </a:r>
+          <a:bodyPr rtlCol="0" anchor="ctr"/>
+          <a:lstStyle/>
+          <a:p>
+            <a:pPr algn="ctr"/>
           </a:p>
         </p:txBody>
       </p:sp>
@@ -4160,18 +4499,18 @@
         </p:nvSpPr>
         <p:spPr>
           <a:xfrm>
-            <a:off x="548640" y="5257800"/>
-            <a:ext cx="11094415" cy="1005840"/>
+            <a:off x="4572000" y="2926080"/>
+            <a:ext cx="7040880" cy="1051560"/>
           </a:xfrm>
           <a:prstGeom prst="roundRect">
             <a:avLst/>
           </a:prstGeom>
           <a:solidFill>
-            <a:srgbClr val="F8FAFC"/>
+            <a:srgbClr val="FFFFFF"/>
           </a:solidFill>
           <a:ln w="19050">
             <a:solidFill>
-              <a:srgbClr val="2563EB"/>
+              <a:srgbClr val="E2E8F0"/>
             </a:solidFill>
           </a:ln>
         </p:spPr>
@@ -4194,14 +4533,14 @@
           <a:lstStyle/>
           <a:p>
             <a:pPr algn="ctr">
-              <a:defRPr sz="1400" b="1">
+              <a:defRPr sz="1300" b="1">
                 <a:solidFill>
                   <a:srgbClr val="2563EB"/>
                 </a:solidFill>
               </a:defRPr>
             </a:pPr>
             <a:r>
-              <a:t>4. Client Confirmation Checkpoint</a:t>
+              <a:t>Checkpoint 2: Guide Assignment Confirmed</a:t>
             </a:r>
           </a:p>
           <a:p>
@@ -4209,15 +4548,282 @@
               <a:spcBef>
                 <a:spcPts val="400"/>
               </a:spcBef>
-              <a:defRPr sz="1200">
+              <a:defRPr sz="1100">
                 <a:solidFill>
                   <a:srgbClr val="1E293B"/>
                 </a:solidFill>
               </a:defRPr>
             </a:pPr>
             <a:r>
-              <a:t>Client B2B tour operator contract signed and initial tour deposit confirmed in system.</a:t>
-            </a:r>
+              <a:t>Primary Tour Guide assigned, language requirements matched, daily rate accepted, and contract locked.</a:t>
+            </a:r>
+          </a:p>
+        </p:txBody>
+      </p:sp>
+      <p:sp>
+        <p:nvSpPr>
+          <p:cNvPr id="10" name="Rectangle 9"/>
+          <p:cNvSpPr/>
+          <p:nvPr/>
+        </p:nvSpPr>
+        <p:spPr>
+          <a:xfrm>
+            <a:off x="4572000" y="2926080"/>
+            <a:ext cx="137160" cy="1051560"/>
+          </a:xfrm>
+          <a:prstGeom prst="rect">
+            <a:avLst/>
+          </a:prstGeom>
+          <a:solidFill>
+            <a:srgbClr val="2563EB"/>
+          </a:solidFill>
+          <a:ln>
+            <a:noFill/>
+          </a:ln>
+        </p:spPr>
+        <p:style>
+          <a:lnRef idx="1">
+            <a:schemeClr val="accent1"/>
+          </a:lnRef>
+          <a:fillRef idx="3">
+            <a:schemeClr val="accent1"/>
+          </a:fillRef>
+          <a:effectRef idx="2">
+            <a:schemeClr val="accent1"/>
+          </a:effectRef>
+          <a:fontRef idx="minor">
+            <a:schemeClr val="lt1"/>
+          </a:fontRef>
+        </p:style>
+        <p:txBody>
+          <a:bodyPr rtlCol="0" anchor="ctr"/>
+          <a:lstStyle/>
+          <a:p>
+            <a:pPr algn="ctr"/>
+          </a:p>
+        </p:txBody>
+      </p:sp>
+      <p:sp>
+        <p:nvSpPr>
+          <p:cNvPr id="11" name="Rounded Rectangle 10"/>
+          <p:cNvSpPr/>
+          <p:nvPr/>
+        </p:nvSpPr>
+        <p:spPr>
+          <a:xfrm>
+            <a:off x="4572000" y="4114800"/>
+            <a:ext cx="7040880" cy="1051560"/>
+          </a:xfrm>
+          <a:prstGeom prst="roundRect">
+            <a:avLst/>
+          </a:prstGeom>
+          <a:solidFill>
+            <a:srgbClr val="FFFFFF"/>
+          </a:solidFill>
+          <a:ln w="19050">
+            <a:solidFill>
+              <a:srgbClr val="E2E8F0"/>
+            </a:solidFill>
+          </a:ln>
+        </p:spPr>
+        <p:style>
+          <a:lnRef idx="1">
+            <a:schemeClr val="accent1"/>
+          </a:lnRef>
+          <a:fillRef idx="3">
+            <a:schemeClr val="accent1"/>
+          </a:fillRef>
+          <a:effectRef idx="2">
+            <a:schemeClr val="accent1"/>
+          </a:effectRef>
+          <a:fontRef idx="minor">
+            <a:schemeClr val="lt1"/>
+          </a:fontRef>
+        </p:style>
+        <p:txBody>
+          <a:bodyPr rtlCol="0" anchor="ctr" wrap="square"/>
+          <a:lstStyle/>
+          <a:p>
+            <a:pPr algn="ctr">
+              <a:defRPr sz="1300" b="1">
+                <a:solidFill>
+                  <a:srgbClr val="2563EB"/>
+                </a:solidFill>
+              </a:defRPr>
+            </a:pPr>
+            <a:r>
+              <a:t>Checkpoint 3: Transportation &amp; Bus Locked</a:t>
+            </a:r>
+          </a:p>
+          <a:p>
+            <a:pPr>
+              <a:spcBef>
+                <a:spcPts val="400"/>
+              </a:spcBef>
+              <a:defRPr sz="1100">
+                <a:solidFill>
+                  <a:srgbClr val="1E293B"/>
+                </a:solidFill>
+              </a:defRPr>
+            </a:pPr>
+            <a:r>
+              <a:t>Transport company &amp; driver assigned. Coach capacity verified (e.g. 50-seat bus for 36 pax).</a:t>
+            </a:r>
+          </a:p>
+        </p:txBody>
+      </p:sp>
+      <p:sp>
+        <p:nvSpPr>
+          <p:cNvPr id="12" name="Rectangle 11"/>
+          <p:cNvSpPr/>
+          <p:nvPr/>
+        </p:nvSpPr>
+        <p:spPr>
+          <a:xfrm>
+            <a:off x="4572000" y="4114800"/>
+            <a:ext cx="137160" cy="1051560"/>
+          </a:xfrm>
+          <a:prstGeom prst="rect">
+            <a:avLst/>
+          </a:prstGeom>
+          <a:solidFill>
+            <a:srgbClr val="2563EB"/>
+          </a:solidFill>
+          <a:ln>
+            <a:noFill/>
+          </a:ln>
+        </p:spPr>
+        <p:style>
+          <a:lnRef idx="1">
+            <a:schemeClr val="accent1"/>
+          </a:lnRef>
+          <a:fillRef idx="3">
+            <a:schemeClr val="accent1"/>
+          </a:fillRef>
+          <a:effectRef idx="2">
+            <a:schemeClr val="accent1"/>
+          </a:effectRef>
+          <a:fontRef idx="minor">
+            <a:schemeClr val="lt1"/>
+          </a:fontRef>
+        </p:style>
+        <p:txBody>
+          <a:bodyPr rtlCol="0" anchor="ctr"/>
+          <a:lstStyle/>
+          <a:p>
+            <a:pPr algn="ctr"/>
+          </a:p>
+        </p:txBody>
+      </p:sp>
+      <p:sp>
+        <p:nvSpPr>
+          <p:cNvPr id="13" name="Rounded Rectangle 12"/>
+          <p:cNvSpPr/>
+          <p:nvPr/>
+        </p:nvSpPr>
+        <p:spPr>
+          <a:xfrm>
+            <a:off x="4572000" y="5303520"/>
+            <a:ext cx="7040880" cy="1051560"/>
+          </a:xfrm>
+          <a:prstGeom prst="roundRect">
+            <a:avLst/>
+          </a:prstGeom>
+          <a:solidFill>
+            <a:srgbClr val="FFFFFF"/>
+          </a:solidFill>
+          <a:ln w="19050">
+            <a:solidFill>
+              <a:srgbClr val="E2E8F0"/>
+            </a:solidFill>
+          </a:ln>
+        </p:spPr>
+        <p:style>
+          <a:lnRef idx="1">
+            <a:schemeClr val="accent1"/>
+          </a:lnRef>
+          <a:fillRef idx="3">
+            <a:schemeClr val="accent1"/>
+          </a:fillRef>
+          <a:effectRef idx="2">
+            <a:schemeClr val="accent1"/>
+          </a:effectRef>
+          <a:fontRef idx="minor">
+            <a:schemeClr val="lt1"/>
+          </a:fontRef>
+        </p:style>
+        <p:txBody>
+          <a:bodyPr rtlCol="0" anchor="ctr" wrap="square"/>
+          <a:lstStyle/>
+          <a:p>
+            <a:pPr algn="ctr">
+              <a:defRPr sz="1300" b="1">
+                <a:solidFill>
+                  <a:srgbClr val="2563EB"/>
+                </a:solidFill>
+              </a:defRPr>
+            </a:pPr>
+            <a:r>
+              <a:t>Checkpoint 4: Client Deposit &amp; Contract Confirmed</a:t>
+            </a:r>
+          </a:p>
+          <a:p>
+            <a:pPr>
+              <a:spcBef>
+                <a:spcPts val="400"/>
+              </a:spcBef>
+              <a:defRPr sz="1100">
+                <a:solidFill>
+                  <a:srgbClr val="1E293B"/>
+                </a:solidFill>
+              </a:defRPr>
+            </a:pPr>
+            <a:r>
+              <a:t>Client B2B tour operator contract signed and initial deposit payment received.</a:t>
+            </a:r>
+          </a:p>
+        </p:txBody>
+      </p:sp>
+      <p:sp>
+        <p:nvSpPr>
+          <p:cNvPr id="14" name="Rectangle 13"/>
+          <p:cNvSpPr/>
+          <p:nvPr/>
+        </p:nvSpPr>
+        <p:spPr>
+          <a:xfrm>
+            <a:off x="4572000" y="5303520"/>
+            <a:ext cx="137160" cy="1051560"/>
+          </a:xfrm>
+          <a:prstGeom prst="rect">
+            <a:avLst/>
+          </a:prstGeom>
+          <a:solidFill>
+            <a:srgbClr val="2563EB"/>
+          </a:solidFill>
+          <a:ln>
+            <a:noFill/>
+          </a:ln>
+        </p:spPr>
+        <p:style>
+          <a:lnRef idx="1">
+            <a:schemeClr val="accent1"/>
+          </a:lnRef>
+          <a:fillRef idx="3">
+            <a:schemeClr val="accent1"/>
+          </a:fillRef>
+          <a:effectRef idx="2">
+            <a:schemeClr val="accent1"/>
+          </a:effectRef>
+          <a:fontRef idx="minor">
+            <a:schemeClr val="lt1"/>
+          </a:fontRef>
+        </p:style>
+        <p:txBody>
+          <a:bodyPr rtlCol="0" anchor="ctr"/>
+          <a:lstStyle/>
+          <a:p>
+            <a:pPr algn="ctr"/>
           </a:p>
         </p:txBody>
       </p:sp>
@@ -4291,7 +4897,7 @@
         <p:spPr>
           <a:xfrm>
             <a:off x="548640" y="137160"/>
-            <a:ext cx="9144000" cy="731520"/>
+            <a:ext cx="8686800" cy="731520"/>
           </a:xfrm>
           <a:prstGeom prst="rect">
             <a:avLst/>
@@ -4312,7 +4918,7 @@
               </a:defRPr>
             </a:pPr>
             <a:r>
-              <a:t>Transition Gate: In Progress -&gt; Completed</a:t>
+              <a:t>Transition Gate 3: Confirmed ➔ In Progress</a:t>
             </a:r>
           </a:p>
         </p:txBody>
@@ -4325,8 +4931,8 @@
         </p:nvSpPr>
         <p:spPr>
           <a:xfrm>
-            <a:off x="9326880" y="274320"/>
-            <a:ext cx="2286000" cy="411480"/>
+            <a:off x="9144000" y="274320"/>
+            <a:ext cx="2468880" cy="411480"/>
           </a:xfrm>
           <a:prstGeom prst="roundRect">
             <a:avLst/>
@@ -4364,56 +4970,21 @@
               </a:defRPr>
             </a:pPr>
             <a:r>
-              <a:t>CLOSING GATES</a:t>
-            </a:r>
-          </a:p>
-        </p:txBody>
-      </p:sp>
-      <p:sp>
-        <p:nvSpPr>
-          <p:cNvPr id="5" name="TextBox 4"/>
-          <p:cNvSpPr txBox="1"/>
-          <p:nvPr/>
-        </p:nvSpPr>
-        <p:spPr>
-          <a:xfrm>
-            <a:off x="548640" y="1188720"/>
-            <a:ext cx="11094415" cy="5303520"/>
-          </a:xfrm>
-          <a:prstGeom prst="rect">
-            <a:avLst/>
-          </a:prstGeom>
-          <a:noFill/>
-        </p:spPr>
-        <p:txBody>
-          <a:bodyPr wrap="square">
-            <a:spAutoFit/>
-          </a:bodyPr>
-          <a:lstStyle/>
-          <a:p>
-            <a:pPr>
-              <a:defRPr sz="1600" b="1">
-                <a:solidFill>
-                  <a:srgbClr val="1E293B"/>
-                </a:solidFill>
-              </a:defRPr>
-            </a:pPr>
-            <a:r>
-              <a:t>To transition a tour status to COMPLETED, the system enforces 3 Completion Criteria:</a:t>
-            </a:r>
-          </a:p>
-        </p:txBody>
-      </p:sp>
-      <p:sp>
-        <p:nvSpPr>
-          <p:cNvPr id="6" name="Rounded Rectangle 5"/>
+              <a:t>GATE 3 (ORDER 3➔4)</a:t>
+            </a:r>
+          </a:p>
+        </p:txBody>
+      </p:sp>
+      <p:sp>
+        <p:nvSpPr>
+          <p:cNvPr id="5" name="Rounded Rectangle 4"/>
           <p:cNvSpPr/>
           <p:nvPr/>
         </p:nvSpPr>
         <p:spPr>
           <a:xfrm>
-            <a:off x="548640" y="2011680"/>
-            <a:ext cx="11094415" cy="1188720"/>
+            <a:off x="548640" y="1280160"/>
+            <a:ext cx="3840480" cy="5120640"/>
           </a:xfrm>
           <a:prstGeom prst="roundRect">
             <a:avLst/>
@@ -4421,9 +4992,9 @@
           <a:solidFill>
             <a:srgbClr val="F8FAFC"/>
           </a:solidFill>
-          <a:ln w="19050">
+          <a:ln w="25400">
             <a:solidFill>
-              <a:srgbClr val="10B981"/>
+              <a:srgbClr val="7C3AED"/>
             </a:solidFill>
           </a:ln>
         </p:spPr>
@@ -4446,14 +5017,14 @@
           <a:lstStyle/>
           <a:p>
             <a:pPr algn="ctr">
-              <a:defRPr sz="1500" b="1">
-                <a:solidFill>
-                  <a:srgbClr val="10B981"/>
-                </a:solidFill>
-              </a:defRPr>
-            </a:pPr>
-            <a:r>
-              <a:t>1. Return Date Reached</a:t>
+              <a:defRPr sz="1200" b="1">
+                <a:solidFill>
+                  <a:srgbClr val="64748B"/>
+                </a:solidFill>
+              </a:defRPr>
+            </a:pPr>
+            <a:r>
+              <a:t>FORWARD TRANSITION</a:t>
             </a:r>
           </a:p>
           <a:p>
@@ -4461,14 +5032,139 @@
               <a:spcBef>
                 <a:spcPts val="600"/>
               </a:spcBef>
-              <a:defRPr sz="1300">
+              <a:defRPr sz="1800" b="1">
+                <a:solidFill>
+                  <a:srgbClr val="7C3AED"/>
+                </a:solidFill>
+              </a:defRPr>
+            </a:pPr>
+            <a:r>
+              <a:t>Confirmed  ➔  In Progress</a:t>
+            </a:r>
+          </a:p>
+          <a:p>
+            <a:pPr>
+              <a:spcBef>
+                <a:spcPts val="1600"/>
+              </a:spcBef>
+              <a:defRPr sz="1300" b="1">
                 <a:solidFill>
                   <a:srgbClr val="1E293B"/>
                 </a:solidFill>
               </a:defRPr>
             </a:pPr>
             <a:r>
-              <a:t>System date ≥ EndDate (Passengers departure completed and flights departed).</a:t>
+              <a:t>Business Meaning &amp; Impact:</a:t>
+            </a:r>
+          </a:p>
+          <a:p>
+            <a:pPr>
+              <a:spcBef>
+                <a:spcPts val="600"/>
+              </a:spcBef>
+              <a:defRPr sz="1100">
+                <a:solidFill>
+                  <a:srgbClr val="64748B"/>
+                </a:solidFill>
+              </a:defRPr>
+            </a:pPr>
+            <a:r>
+              <a:t>Marks active on-the-ground tour execution, daily guide management, and real-time excursion sales.</a:t>
+            </a:r>
+          </a:p>
+          <a:p>
+            <a:pPr>
+              <a:spcBef>
+                <a:spcPts val="1600"/>
+              </a:spcBef>
+              <a:defRPr sz="1300" b="1">
+                <a:solidFill>
+                  <a:srgbClr val="1E293B"/>
+                </a:solidFill>
+              </a:defRPr>
+            </a:pPr>
+            <a:r>
+              <a:t>Automated System Checks:</a:t>
+            </a:r>
+          </a:p>
+          <a:p>
+            <a:pPr>
+              <a:spcBef>
+                <a:spcPts val="400"/>
+              </a:spcBef>
+              <a:defRPr sz="1100">
+                <a:solidFill>
+                  <a:srgbClr val="7C3AED"/>
+                </a:solidFill>
+              </a:defRPr>
+            </a:pPr>
+            <a:r>
+              <a:t>• CurrentDate &gt;= ArrivalDate</a:t>
+            </a:r>
+          </a:p>
+          <a:p>
+            <a:pPr>
+              <a:spcBef>
+                <a:spcPts val="400"/>
+              </a:spcBef>
+              <a:defRPr sz="1100">
+                <a:solidFill>
+                  <a:srgbClr val="7C3AED"/>
+                </a:solidFill>
+              </a:defRPr>
+            </a:pPr>
+            <a:r>
+              <a:t>• FlightManifestVerified == true</a:t>
+            </a:r>
+          </a:p>
+          <a:p>
+            <a:pPr>
+              <a:spcBef>
+                <a:spcPts val="400"/>
+              </a:spcBef>
+              <a:defRPr sz="1100">
+                <a:solidFill>
+                  <a:srgbClr val="7C3AED"/>
+                </a:solidFill>
+              </a:defRPr>
+            </a:pPr>
+            <a:r>
+              <a:t>• RoomingListDispatched == true</a:t>
+            </a:r>
+          </a:p>
+        </p:txBody>
+      </p:sp>
+      <p:sp>
+        <p:nvSpPr>
+          <p:cNvPr id="6" name="TextBox 5"/>
+          <p:cNvSpPr txBox="1"/>
+          <p:nvPr/>
+        </p:nvSpPr>
+        <p:spPr>
+          <a:xfrm>
+            <a:off x="4572000" y="1188720"/>
+            <a:ext cx="7040880" cy="5212080"/>
+          </a:xfrm>
+          <a:prstGeom prst="rect">
+            <a:avLst/>
+          </a:prstGeom>
+          <a:noFill/>
+        </p:spPr>
+        <p:txBody>
+          <a:bodyPr wrap="square">
+            <a:spAutoFit/>
+          </a:bodyPr>
+          <a:lstStyle/>
+          <a:p>
+            <a:pPr>
+              <a:defRPr sz="1500" b="1">
+                <a:solidFill>
+                  <a:srgbClr val="1E293B"/>
+                </a:solidFill>
+              </a:defRPr>
+            </a:pPr>
+            <a:r>
+              <a:t>Mandatory Transition Checkpoints (100% Pass Required):</a:t>
             </a:r>
           </a:p>
         </p:txBody>
@@ -4481,18 +5177,18 @@
         </p:nvSpPr>
         <p:spPr>
           <a:xfrm>
-            <a:off x="548640" y="3383280"/>
-            <a:ext cx="11094415" cy="1188720"/>
+            <a:off x="4572000" y="1737360"/>
+            <a:ext cx="7040880" cy="1051560"/>
           </a:xfrm>
           <a:prstGeom prst="roundRect">
             <a:avLst/>
           </a:prstGeom>
           <a:solidFill>
-            <a:srgbClr val="F8FAFC"/>
+            <a:srgbClr val="FFFFFF"/>
           </a:solidFill>
           <a:ln w="19050">
             <a:solidFill>
-              <a:srgbClr val="10B981"/>
+              <a:srgbClr val="E2E8F0"/>
             </a:solidFill>
           </a:ln>
         </p:spPr>
@@ -4515,54 +5211,52 @@
           <a:lstStyle/>
           <a:p>
             <a:pPr algn="ctr">
-              <a:defRPr sz="1500" b="1">
-                <a:solidFill>
-                  <a:srgbClr val="10B981"/>
-                </a:solidFill>
-              </a:defRPr>
-            </a:pPr>
-            <a:r>
-              <a:t>2. 100% Expenses &amp; Revenue Reconciliation</a:t>
+              <a:defRPr sz="1300" b="1">
+                <a:solidFill>
+                  <a:srgbClr val="7C3AED"/>
+                </a:solidFill>
+              </a:defRPr>
+            </a:pPr>
+            <a:r>
+              <a:t>Checkpoint 1: Arrival Date Reached</a:t>
             </a:r>
           </a:p>
           <a:p>
             <a:pPr>
               <a:spcBef>
-                <a:spcPts val="600"/>
+                <a:spcPts val="400"/>
               </a:spcBef>
-              <a:defRPr sz="1300">
+              <a:defRPr sz="1100">
                 <a:solidFill>
                   <a:srgbClr val="1E293B"/>
                 </a:solidFill>
               </a:defRPr>
             </a:pPr>
             <a:r>
-              <a:t>All supplier invoice costs (Hotels, Guides, Transport, Extras) and client revenue items entered and matched.</a:t>
-            </a:r>
-          </a:p>
-        </p:txBody>
-      </p:sp>
-      <p:sp>
-        <p:nvSpPr>
-          <p:cNvPr id="8" name="Rounded Rectangle 7"/>
+              <a:t>Current system date ≥ ArrivalDate (Arrival date threshold reached).</a:t>
+            </a:r>
+          </a:p>
+        </p:txBody>
+      </p:sp>
+      <p:sp>
+        <p:nvSpPr>
+          <p:cNvPr id="8" name="Rectangle 7"/>
           <p:cNvSpPr/>
           <p:nvPr/>
         </p:nvSpPr>
         <p:spPr>
           <a:xfrm>
-            <a:off x="548640" y="4754880"/>
-            <a:ext cx="11094415" cy="1188720"/>
-          </a:xfrm>
-          <a:prstGeom prst="roundRect">
+            <a:off x="4572000" y="1737360"/>
+            <a:ext cx="137160" cy="1051560"/>
+          </a:xfrm>
+          <a:prstGeom prst="rect">
             <a:avLst/>
           </a:prstGeom>
           <a:solidFill>
-            <a:srgbClr val="F8FAFC"/>
-          </a:solidFill>
-          <a:ln w="19050">
-            <a:solidFill>
-              <a:srgbClr val="10B981"/>
-            </a:solidFill>
+            <a:srgbClr val="7C3AED"/>
+          </a:solidFill>
+          <a:ln>
+            <a:noFill/>
           </a:ln>
         </p:spPr>
         <p:style>
@@ -4580,34 +5274,346 @@
           </a:fontRef>
         </p:style>
         <p:txBody>
+          <a:bodyPr rtlCol="0" anchor="ctr"/>
+          <a:lstStyle/>
+          <a:p>
+            <a:pPr algn="ctr"/>
+          </a:p>
+        </p:txBody>
+      </p:sp>
+      <p:sp>
+        <p:nvSpPr>
+          <p:cNvPr id="9" name="Rounded Rectangle 8"/>
+          <p:cNvSpPr/>
+          <p:nvPr/>
+        </p:nvSpPr>
+        <p:spPr>
+          <a:xfrm>
+            <a:off x="4572000" y="2926080"/>
+            <a:ext cx="7040880" cy="1051560"/>
+          </a:xfrm>
+          <a:prstGeom prst="roundRect">
+            <a:avLst/>
+          </a:prstGeom>
+          <a:solidFill>
+            <a:srgbClr val="FFFFFF"/>
+          </a:solidFill>
+          <a:ln w="19050">
+            <a:solidFill>
+              <a:srgbClr val="E2E8F0"/>
+            </a:solidFill>
+          </a:ln>
+        </p:spPr>
+        <p:style>
+          <a:lnRef idx="1">
+            <a:schemeClr val="accent1"/>
+          </a:lnRef>
+          <a:fillRef idx="3">
+            <a:schemeClr val="accent1"/>
+          </a:fillRef>
+          <a:effectRef idx="2">
+            <a:schemeClr val="accent1"/>
+          </a:effectRef>
+          <a:fontRef idx="minor">
+            <a:schemeClr val="lt1"/>
+          </a:fontRef>
+        </p:style>
+        <p:txBody>
           <a:bodyPr rtlCol="0" anchor="ctr" wrap="square"/>
           <a:lstStyle/>
           <a:p>
             <a:pPr algn="ctr">
-              <a:defRPr sz="1500" b="1">
-                <a:solidFill>
-                  <a:srgbClr val="10B981"/>
-                </a:solidFill>
-              </a:defRPr>
-            </a:pPr>
-            <a:r>
-              <a:t>3. Accounting Closed Flag</a:t>
+              <a:defRPr sz="1300" b="1">
+                <a:solidFill>
+                  <a:srgbClr val="7C3AED"/>
+                </a:solidFill>
+              </a:defRPr>
+            </a:pPr>
+            <a:r>
+              <a:t>Checkpoint 2: Flight &amp; Arrival Manifest Landed</a:t>
             </a:r>
           </a:p>
           <a:p>
             <a:pPr>
               <a:spcBef>
-                <a:spcPts val="600"/>
+                <a:spcPts val="400"/>
               </a:spcBef>
-              <a:defRPr sz="1300">
+              <a:defRPr sz="1100">
                 <a:solidFill>
                   <a:srgbClr val="1E293B"/>
                 </a:solidFill>
               </a:defRPr>
             </a:pPr>
             <a:r>
-              <a:t>Financial accounting audit completed and locked by Finance Administrator.</a:t>
-            </a:r>
+              <a:t>Passenger arrival flight numbers &amp; airport arrival list verified by DMC airport representative.</a:t>
+            </a:r>
+          </a:p>
+        </p:txBody>
+      </p:sp>
+      <p:sp>
+        <p:nvSpPr>
+          <p:cNvPr id="10" name="Rectangle 9"/>
+          <p:cNvSpPr/>
+          <p:nvPr/>
+        </p:nvSpPr>
+        <p:spPr>
+          <a:xfrm>
+            <a:off x="4572000" y="2926080"/>
+            <a:ext cx="137160" cy="1051560"/>
+          </a:xfrm>
+          <a:prstGeom prst="rect">
+            <a:avLst/>
+          </a:prstGeom>
+          <a:solidFill>
+            <a:srgbClr val="7C3AED"/>
+          </a:solidFill>
+          <a:ln>
+            <a:noFill/>
+          </a:ln>
+        </p:spPr>
+        <p:style>
+          <a:lnRef idx="1">
+            <a:schemeClr val="accent1"/>
+          </a:lnRef>
+          <a:fillRef idx="3">
+            <a:schemeClr val="accent1"/>
+          </a:fillRef>
+          <a:effectRef idx="2">
+            <a:schemeClr val="accent1"/>
+          </a:effectRef>
+          <a:fontRef idx="minor">
+            <a:schemeClr val="lt1"/>
+          </a:fontRef>
+        </p:style>
+        <p:txBody>
+          <a:bodyPr rtlCol="0" anchor="ctr"/>
+          <a:lstStyle/>
+          <a:p>
+            <a:pPr algn="ctr"/>
+          </a:p>
+        </p:txBody>
+      </p:sp>
+      <p:sp>
+        <p:nvSpPr>
+          <p:cNvPr id="11" name="Rounded Rectangle 10"/>
+          <p:cNvSpPr/>
+          <p:nvPr/>
+        </p:nvSpPr>
+        <p:spPr>
+          <a:xfrm>
+            <a:off x="4572000" y="4114800"/>
+            <a:ext cx="7040880" cy="1051560"/>
+          </a:xfrm>
+          <a:prstGeom prst="roundRect">
+            <a:avLst/>
+          </a:prstGeom>
+          <a:solidFill>
+            <a:srgbClr val="FFFFFF"/>
+          </a:solidFill>
+          <a:ln w="19050">
+            <a:solidFill>
+              <a:srgbClr val="E2E8F0"/>
+            </a:solidFill>
+          </a:ln>
+        </p:spPr>
+        <p:style>
+          <a:lnRef idx="1">
+            <a:schemeClr val="accent1"/>
+          </a:lnRef>
+          <a:fillRef idx="3">
+            <a:schemeClr val="accent1"/>
+          </a:fillRef>
+          <a:effectRef idx="2">
+            <a:schemeClr val="accent1"/>
+          </a:effectRef>
+          <a:fontRef idx="minor">
+            <a:schemeClr val="lt1"/>
+          </a:fontRef>
+        </p:style>
+        <p:txBody>
+          <a:bodyPr rtlCol="0" anchor="ctr" wrap="square"/>
+          <a:lstStyle/>
+          <a:p>
+            <a:pPr algn="ctr">
+              <a:defRPr sz="1300" b="1">
+                <a:solidFill>
+                  <a:srgbClr val="7C3AED"/>
+                </a:solidFill>
+              </a:defRPr>
+            </a:pPr>
+            <a:r>
+              <a:t>Checkpoint 3: Rooming List Dispatched</a:t>
+            </a:r>
+          </a:p>
+          <a:p>
+            <a:pPr>
+              <a:spcBef>
+                <a:spcPts val="400"/>
+              </a:spcBef>
+              <a:defRPr sz="1100">
+                <a:solidFill>
+                  <a:srgbClr val="1E293B"/>
+                </a:solidFill>
+              </a:defRPr>
+            </a:pPr>
+            <a:r>
+              <a:t>Final rooming lists handed over to hotel reception desks for smooth group check-in.</a:t>
+            </a:r>
+          </a:p>
+        </p:txBody>
+      </p:sp>
+      <p:sp>
+        <p:nvSpPr>
+          <p:cNvPr id="12" name="Rectangle 11"/>
+          <p:cNvSpPr/>
+          <p:nvPr/>
+        </p:nvSpPr>
+        <p:spPr>
+          <a:xfrm>
+            <a:off x="4572000" y="4114800"/>
+            <a:ext cx="137160" cy="1051560"/>
+          </a:xfrm>
+          <a:prstGeom prst="rect">
+            <a:avLst/>
+          </a:prstGeom>
+          <a:solidFill>
+            <a:srgbClr val="7C3AED"/>
+          </a:solidFill>
+          <a:ln>
+            <a:noFill/>
+          </a:ln>
+        </p:spPr>
+        <p:style>
+          <a:lnRef idx="1">
+            <a:schemeClr val="accent1"/>
+          </a:lnRef>
+          <a:fillRef idx="3">
+            <a:schemeClr val="accent1"/>
+          </a:fillRef>
+          <a:effectRef idx="2">
+            <a:schemeClr val="accent1"/>
+          </a:effectRef>
+          <a:fontRef idx="minor">
+            <a:schemeClr val="lt1"/>
+          </a:fontRef>
+        </p:style>
+        <p:txBody>
+          <a:bodyPr rtlCol="0" anchor="ctr"/>
+          <a:lstStyle/>
+          <a:p>
+            <a:pPr algn="ctr"/>
+          </a:p>
+        </p:txBody>
+      </p:sp>
+      <p:sp>
+        <p:nvSpPr>
+          <p:cNvPr id="13" name="Rounded Rectangle 12"/>
+          <p:cNvSpPr/>
+          <p:nvPr/>
+        </p:nvSpPr>
+        <p:spPr>
+          <a:xfrm>
+            <a:off x="4572000" y="5303520"/>
+            <a:ext cx="7040880" cy="1051560"/>
+          </a:xfrm>
+          <a:prstGeom prst="roundRect">
+            <a:avLst/>
+          </a:prstGeom>
+          <a:solidFill>
+            <a:srgbClr val="FFFFFF"/>
+          </a:solidFill>
+          <a:ln w="19050">
+            <a:solidFill>
+              <a:srgbClr val="E2E8F0"/>
+            </a:solidFill>
+          </a:ln>
+        </p:spPr>
+        <p:style>
+          <a:lnRef idx="1">
+            <a:schemeClr val="accent1"/>
+          </a:lnRef>
+          <a:fillRef idx="3">
+            <a:schemeClr val="accent1"/>
+          </a:fillRef>
+          <a:effectRef idx="2">
+            <a:schemeClr val="accent1"/>
+          </a:effectRef>
+          <a:fontRef idx="minor">
+            <a:schemeClr val="lt1"/>
+          </a:fontRef>
+        </p:style>
+        <p:txBody>
+          <a:bodyPr rtlCol="0" anchor="ctr" wrap="square"/>
+          <a:lstStyle/>
+          <a:p>
+            <a:pPr algn="ctr">
+              <a:defRPr sz="1300" b="1">
+                <a:solidFill>
+                  <a:srgbClr val="7C3AED"/>
+                </a:solidFill>
+              </a:defRPr>
+            </a:pPr>
+            <a:r>
+              <a:t>Checkpoint 4: Guide Daily Operational Log Active</a:t>
+            </a:r>
+          </a:p>
+          <a:p>
+            <a:pPr>
+              <a:spcBef>
+                <a:spcPts val="400"/>
+              </a:spcBef>
+              <a:defRPr sz="1100">
+                <a:solidFill>
+                  <a:srgbClr val="1E293B"/>
+                </a:solidFill>
+              </a:defRPr>
+            </a:pPr>
+            <a:r>
+              <a:t>Tour Guide checked in on-site and daily cash remittance tracker initialized.</a:t>
+            </a:r>
+          </a:p>
+        </p:txBody>
+      </p:sp>
+      <p:sp>
+        <p:nvSpPr>
+          <p:cNvPr id="14" name="Rectangle 13"/>
+          <p:cNvSpPr/>
+          <p:nvPr/>
+        </p:nvSpPr>
+        <p:spPr>
+          <a:xfrm>
+            <a:off x="4572000" y="5303520"/>
+            <a:ext cx="137160" cy="1051560"/>
+          </a:xfrm>
+          <a:prstGeom prst="rect">
+            <a:avLst/>
+          </a:prstGeom>
+          <a:solidFill>
+            <a:srgbClr val="7C3AED"/>
+          </a:solidFill>
+          <a:ln>
+            <a:noFill/>
+          </a:ln>
+        </p:spPr>
+        <p:style>
+          <a:lnRef idx="1">
+            <a:schemeClr val="accent1"/>
+          </a:lnRef>
+          <a:fillRef idx="3">
+            <a:schemeClr val="accent1"/>
+          </a:fillRef>
+          <a:effectRef idx="2">
+            <a:schemeClr val="accent1"/>
+          </a:effectRef>
+          <a:fontRef idx="minor">
+            <a:schemeClr val="lt1"/>
+          </a:fontRef>
+        </p:style>
+        <p:txBody>
+          <a:bodyPr rtlCol="0" anchor="ctr"/>
+          <a:lstStyle/>
+          <a:p>
+            <a:pPr algn="ctr"/>
           </a:p>
         </p:txBody>
       </p:sp>
@@ -4681,7 +5687,7 @@
         <p:spPr>
           <a:xfrm>
             <a:off x="548640" y="137160"/>
-            <a:ext cx="9144000" cy="731520"/>
+            <a:ext cx="8686800" cy="731520"/>
           </a:xfrm>
           <a:prstGeom prst="rect">
             <a:avLst/>
@@ -4702,7 +5708,7 @@
               </a:defRPr>
             </a:pPr>
             <a:r>
-              <a:t>Automated SLA Warning Notification Module</a:t>
+              <a:t>Transition Gate 4: In Progress ➔ Completed</a:t>
             </a:r>
           </a:p>
         </p:txBody>
@@ -4715,8 +5721,8 @@
         </p:nvSpPr>
         <p:spPr>
           <a:xfrm>
-            <a:off x="9326880" y="274320"/>
-            <a:ext cx="2286000" cy="411480"/>
+            <a:off x="9144000" y="274320"/>
+            <a:ext cx="2468880" cy="411480"/>
           </a:xfrm>
           <a:prstGeom prst="roundRect">
             <a:avLst/>
@@ -4754,21 +5760,180 @@
               </a:defRPr>
             </a:pPr>
             <a:r>
-              <a:t>WARNING SYSTEM</a:t>
-            </a:r>
-          </a:p>
-        </p:txBody>
-      </p:sp>
-      <p:sp>
-        <p:nvSpPr>
-          <p:cNvPr id="5" name="TextBox 4"/>
+              <a:t>GATE 4 (ORDER 4➔5)</a:t>
+            </a:r>
+          </a:p>
+        </p:txBody>
+      </p:sp>
+      <p:sp>
+        <p:nvSpPr>
+          <p:cNvPr id="5" name="Rounded Rectangle 4"/>
+          <p:cNvSpPr/>
+          <p:nvPr/>
+        </p:nvSpPr>
+        <p:spPr>
+          <a:xfrm>
+            <a:off x="548640" y="1280160"/>
+            <a:ext cx="3840480" cy="5120640"/>
+          </a:xfrm>
+          <a:prstGeom prst="roundRect">
+            <a:avLst/>
+          </a:prstGeom>
+          <a:solidFill>
+            <a:srgbClr val="F8FAFC"/>
+          </a:solidFill>
+          <a:ln w="25400">
+            <a:solidFill>
+              <a:srgbClr val="10B981"/>
+            </a:solidFill>
+          </a:ln>
+        </p:spPr>
+        <p:style>
+          <a:lnRef idx="1">
+            <a:schemeClr val="accent1"/>
+          </a:lnRef>
+          <a:fillRef idx="3">
+            <a:schemeClr val="accent1"/>
+          </a:fillRef>
+          <a:effectRef idx="2">
+            <a:schemeClr val="accent1"/>
+          </a:effectRef>
+          <a:fontRef idx="minor">
+            <a:schemeClr val="lt1"/>
+          </a:fontRef>
+        </p:style>
+        <p:txBody>
+          <a:bodyPr rtlCol="0" anchor="ctr" wrap="square"/>
+          <a:lstStyle/>
+          <a:p>
+            <a:pPr algn="ctr">
+              <a:defRPr sz="1200" b="1">
+                <a:solidFill>
+                  <a:srgbClr val="64748B"/>
+                </a:solidFill>
+              </a:defRPr>
+            </a:pPr>
+            <a:r>
+              <a:t>FORWARD TRANSITION</a:t>
+            </a:r>
+          </a:p>
+          <a:p>
+            <a:pPr>
+              <a:spcBef>
+                <a:spcPts val="600"/>
+              </a:spcBef>
+              <a:defRPr sz="1800" b="1">
+                <a:solidFill>
+                  <a:srgbClr val="10B981"/>
+                </a:solidFill>
+              </a:defRPr>
+            </a:pPr>
+            <a:r>
+              <a:t>In Progress  ➔  Completed</a:t>
+            </a:r>
+          </a:p>
+          <a:p>
+            <a:pPr>
+              <a:spcBef>
+                <a:spcPts val="1600"/>
+              </a:spcBef>
+              <a:defRPr sz="1300" b="1">
+                <a:solidFill>
+                  <a:srgbClr val="1E293B"/>
+                </a:solidFill>
+              </a:defRPr>
+            </a:pPr>
+            <a:r>
+              <a:t>Business Meaning &amp; Impact:</a:t>
+            </a:r>
+          </a:p>
+          <a:p>
+            <a:pPr>
+              <a:spcBef>
+                <a:spcPts val="600"/>
+              </a:spcBef>
+              <a:defRPr sz="1100">
+                <a:solidFill>
+                  <a:srgbClr val="64748B"/>
+                </a:solidFill>
+              </a:defRPr>
+            </a:pPr>
+            <a:r>
+              <a:t>Finalizes tour operations, seals financial accounts, and prevents further unauthorized expense edits.</a:t>
+            </a:r>
+          </a:p>
+          <a:p>
+            <a:pPr>
+              <a:spcBef>
+                <a:spcPts val="1600"/>
+              </a:spcBef>
+              <a:defRPr sz="1300" b="1">
+                <a:solidFill>
+                  <a:srgbClr val="1E293B"/>
+                </a:solidFill>
+              </a:defRPr>
+            </a:pPr>
+            <a:r>
+              <a:t>Automated System Checks:</a:t>
+            </a:r>
+          </a:p>
+          <a:p>
+            <a:pPr>
+              <a:spcBef>
+                <a:spcPts val="400"/>
+              </a:spcBef>
+              <a:defRPr sz="1100">
+                <a:solidFill>
+                  <a:srgbClr val="10B981"/>
+                </a:solidFill>
+              </a:defRPr>
+            </a:pPr>
+            <a:r>
+              <a:t>• CurrentDate &gt;= EndDate</a:t>
+            </a:r>
+          </a:p>
+          <a:p>
+            <a:pPr>
+              <a:spcBef>
+                <a:spcPts val="400"/>
+              </a:spcBef>
+              <a:defRPr sz="1100">
+                <a:solidFill>
+                  <a:srgbClr val="10B981"/>
+                </a:solidFill>
+              </a:defRPr>
+            </a:pPr>
+            <a:r>
+              <a:t>• UninvoicedSupplierCount == 0</a:t>
+            </a:r>
+          </a:p>
+          <a:p>
+            <a:pPr>
+              <a:spcBef>
+                <a:spcPts val="400"/>
+              </a:spcBef>
+              <a:defRPr sz="1100">
+                <a:solidFill>
+                  <a:srgbClr val="10B981"/>
+                </a:solidFill>
+              </a:defRPr>
+            </a:pPr>
+            <a:r>
+              <a:t>• AccountingClosed == true</a:t>
+            </a:r>
+          </a:p>
+        </p:txBody>
+      </p:sp>
+      <p:sp>
+        <p:nvSpPr>
+          <p:cNvPr id="6" name="TextBox 5"/>
           <p:cNvSpPr txBox="1"/>
           <p:nvPr/>
         </p:nvSpPr>
         <p:spPr>
           <a:xfrm>
-            <a:off x="548640" y="1188720"/>
-            <a:ext cx="11094415" cy="5303520"/>
+            <a:off x="4572000" y="1188720"/>
+            <a:ext cx="7040880" cy="5212080"/>
           </a:xfrm>
           <a:prstGeom prst="rect">
             <a:avLst/>
@@ -4782,21 +5947,1295 @@
           <a:lstStyle/>
           <a:p>
             <a:pPr>
-              <a:defRPr sz="1600" b="1">
+              <a:defRPr sz="1500" b="1">
                 <a:solidFill>
                   <a:srgbClr val="1E293B"/>
                 </a:solidFill>
               </a:defRPr>
             </a:pPr>
             <a:r>
-              <a:t>Automated Time-Window Warning Notifications:</a:t>
-            </a:r>
-          </a:p>
-        </p:txBody>
-      </p:sp>
-      <p:sp>
-        <p:nvSpPr>
-          <p:cNvPr id="6" name="Rounded Rectangle 5"/>
+              <a:t>Mandatory Transition Checkpoints (100% Pass Required):</a:t>
+            </a:r>
+          </a:p>
+        </p:txBody>
+      </p:sp>
+      <p:sp>
+        <p:nvSpPr>
+          <p:cNvPr id="7" name="Rounded Rectangle 6"/>
+          <p:cNvSpPr/>
+          <p:nvPr/>
+        </p:nvSpPr>
+        <p:spPr>
+          <a:xfrm>
+            <a:off x="4572000" y="1737360"/>
+            <a:ext cx="7040880" cy="1051560"/>
+          </a:xfrm>
+          <a:prstGeom prst="roundRect">
+            <a:avLst/>
+          </a:prstGeom>
+          <a:solidFill>
+            <a:srgbClr val="FFFFFF"/>
+          </a:solidFill>
+          <a:ln w="19050">
+            <a:solidFill>
+              <a:srgbClr val="E2E8F0"/>
+            </a:solidFill>
+          </a:ln>
+        </p:spPr>
+        <p:style>
+          <a:lnRef idx="1">
+            <a:schemeClr val="accent1"/>
+          </a:lnRef>
+          <a:fillRef idx="3">
+            <a:schemeClr val="accent1"/>
+          </a:fillRef>
+          <a:effectRef idx="2">
+            <a:schemeClr val="accent1"/>
+          </a:effectRef>
+          <a:fontRef idx="minor">
+            <a:schemeClr val="lt1"/>
+          </a:fontRef>
+        </p:style>
+        <p:txBody>
+          <a:bodyPr rtlCol="0" anchor="ctr" wrap="square"/>
+          <a:lstStyle/>
+          <a:p>
+            <a:pPr algn="ctr">
+              <a:defRPr sz="1300" b="1">
+                <a:solidFill>
+                  <a:srgbClr val="10B981"/>
+                </a:solidFill>
+              </a:defRPr>
+            </a:pPr>
+            <a:r>
+              <a:t>Checkpoint 1: Return Date Reached (Passengers Departed)</a:t>
+            </a:r>
+          </a:p>
+          <a:p>
+            <a:pPr>
+              <a:spcBef>
+                <a:spcPts val="400"/>
+              </a:spcBef>
+              <a:defRPr sz="1100">
+                <a:solidFill>
+                  <a:srgbClr val="1E293B"/>
+                </a:solidFill>
+              </a:defRPr>
+            </a:pPr>
+            <a:r>
+              <a:t>Current system date ≥ EndDate. Passengers departure transfer completed &amp; flights departed.</a:t>
+            </a:r>
+          </a:p>
+        </p:txBody>
+      </p:sp>
+      <p:sp>
+        <p:nvSpPr>
+          <p:cNvPr id="8" name="Rectangle 7"/>
+          <p:cNvSpPr/>
+          <p:nvPr/>
+        </p:nvSpPr>
+        <p:spPr>
+          <a:xfrm>
+            <a:off x="4572000" y="1737360"/>
+            <a:ext cx="137160" cy="1051560"/>
+          </a:xfrm>
+          <a:prstGeom prst="rect">
+            <a:avLst/>
+          </a:prstGeom>
+          <a:solidFill>
+            <a:srgbClr val="10B981"/>
+          </a:solidFill>
+          <a:ln>
+            <a:noFill/>
+          </a:ln>
+        </p:spPr>
+        <p:style>
+          <a:lnRef idx="1">
+            <a:schemeClr val="accent1"/>
+          </a:lnRef>
+          <a:fillRef idx="3">
+            <a:schemeClr val="accent1"/>
+          </a:fillRef>
+          <a:effectRef idx="2">
+            <a:schemeClr val="accent1"/>
+          </a:effectRef>
+          <a:fontRef idx="minor">
+            <a:schemeClr val="lt1"/>
+          </a:fontRef>
+        </p:style>
+        <p:txBody>
+          <a:bodyPr rtlCol="0" anchor="ctr"/>
+          <a:lstStyle/>
+          <a:p>
+            <a:pPr algn="ctr"/>
+          </a:p>
+        </p:txBody>
+      </p:sp>
+      <p:sp>
+        <p:nvSpPr>
+          <p:cNvPr id="9" name="Rounded Rectangle 8"/>
+          <p:cNvSpPr/>
+          <p:nvPr/>
+        </p:nvSpPr>
+        <p:spPr>
+          <a:xfrm>
+            <a:off x="4572000" y="2926080"/>
+            <a:ext cx="7040880" cy="1051560"/>
+          </a:xfrm>
+          <a:prstGeom prst="roundRect">
+            <a:avLst/>
+          </a:prstGeom>
+          <a:solidFill>
+            <a:srgbClr val="FFFFFF"/>
+          </a:solidFill>
+          <a:ln w="19050">
+            <a:solidFill>
+              <a:srgbClr val="E2E8F0"/>
+            </a:solidFill>
+          </a:ln>
+        </p:spPr>
+        <p:style>
+          <a:lnRef idx="1">
+            <a:schemeClr val="accent1"/>
+          </a:lnRef>
+          <a:fillRef idx="3">
+            <a:schemeClr val="accent1"/>
+          </a:fillRef>
+          <a:effectRef idx="2">
+            <a:schemeClr val="accent1"/>
+          </a:effectRef>
+          <a:fontRef idx="minor">
+            <a:schemeClr val="lt1"/>
+          </a:fontRef>
+        </p:style>
+        <p:txBody>
+          <a:bodyPr rtlCol="0" anchor="ctr" wrap="square"/>
+          <a:lstStyle/>
+          <a:p>
+            <a:pPr algn="ctr">
+              <a:defRPr sz="1300" b="1">
+                <a:solidFill>
+                  <a:srgbClr val="10B981"/>
+                </a:solidFill>
+              </a:defRPr>
+            </a:pPr>
+            <a:r>
+              <a:t>Checkpoint 2: 100% Supplier Expense Reconciliation</a:t>
+            </a:r>
+          </a:p>
+          <a:p>
+            <a:pPr>
+              <a:spcBef>
+                <a:spcPts val="400"/>
+              </a:spcBef>
+              <a:defRPr sz="1100">
+                <a:solidFill>
+                  <a:srgbClr val="1E293B"/>
+                </a:solidFill>
+              </a:defRPr>
+            </a:pPr>
+            <a:r>
+              <a:t>All supplier costs (Hotels, Guides, Transport, Excursions, Extras) entered &amp; invoice-verified.</a:t>
+            </a:r>
+          </a:p>
+        </p:txBody>
+      </p:sp>
+      <p:sp>
+        <p:nvSpPr>
+          <p:cNvPr id="10" name="Rectangle 9"/>
+          <p:cNvSpPr/>
+          <p:nvPr/>
+        </p:nvSpPr>
+        <p:spPr>
+          <a:xfrm>
+            <a:off x="4572000" y="2926080"/>
+            <a:ext cx="137160" cy="1051560"/>
+          </a:xfrm>
+          <a:prstGeom prst="rect">
+            <a:avLst/>
+          </a:prstGeom>
+          <a:solidFill>
+            <a:srgbClr val="10B981"/>
+          </a:solidFill>
+          <a:ln>
+            <a:noFill/>
+          </a:ln>
+        </p:spPr>
+        <p:style>
+          <a:lnRef idx="1">
+            <a:schemeClr val="accent1"/>
+          </a:lnRef>
+          <a:fillRef idx="3">
+            <a:schemeClr val="accent1"/>
+          </a:fillRef>
+          <a:effectRef idx="2">
+            <a:schemeClr val="accent1"/>
+          </a:effectRef>
+          <a:fontRef idx="minor">
+            <a:schemeClr val="lt1"/>
+          </a:fontRef>
+        </p:style>
+        <p:txBody>
+          <a:bodyPr rtlCol="0" anchor="ctr"/>
+          <a:lstStyle/>
+          <a:p>
+            <a:pPr algn="ctr"/>
+          </a:p>
+        </p:txBody>
+      </p:sp>
+      <p:sp>
+        <p:nvSpPr>
+          <p:cNvPr id="11" name="Rounded Rectangle 10"/>
+          <p:cNvSpPr/>
+          <p:nvPr/>
+        </p:nvSpPr>
+        <p:spPr>
+          <a:xfrm>
+            <a:off x="4572000" y="4114800"/>
+            <a:ext cx="7040880" cy="1051560"/>
+          </a:xfrm>
+          <a:prstGeom prst="roundRect">
+            <a:avLst/>
+          </a:prstGeom>
+          <a:solidFill>
+            <a:srgbClr val="FFFFFF"/>
+          </a:solidFill>
+          <a:ln w="19050">
+            <a:solidFill>
+              <a:srgbClr val="E2E8F0"/>
+            </a:solidFill>
+          </a:ln>
+        </p:spPr>
+        <p:style>
+          <a:lnRef idx="1">
+            <a:schemeClr val="accent1"/>
+          </a:lnRef>
+          <a:fillRef idx="3">
+            <a:schemeClr val="accent1"/>
+          </a:fillRef>
+          <a:effectRef idx="2">
+            <a:schemeClr val="accent1"/>
+          </a:effectRef>
+          <a:fontRef idx="minor">
+            <a:schemeClr val="lt1"/>
+          </a:fontRef>
+        </p:style>
+        <p:txBody>
+          <a:bodyPr rtlCol="0" anchor="ctr" wrap="square"/>
+          <a:lstStyle/>
+          <a:p>
+            <a:pPr algn="ctr">
+              <a:defRPr sz="1300" b="1">
+                <a:solidFill>
+                  <a:srgbClr val="10B981"/>
+                </a:solidFill>
+              </a:defRPr>
+            </a:pPr>
+            <a:r>
+              <a:t>Checkpoint 3: 100% Client Revenue Reconciliation</a:t>
+            </a:r>
+          </a:p>
+          <a:p>
+            <a:pPr>
+              <a:spcBef>
+                <a:spcPts val="400"/>
+              </a:spcBef>
+              <a:defRPr sz="1100">
+                <a:solidFill>
+                  <a:srgbClr val="1E293B"/>
+                </a:solidFill>
+              </a:defRPr>
+            </a:pPr>
+            <a:r>
+              <a:t>All client billable items &amp; invoices issued and reconciled against client ledger.</a:t>
+            </a:r>
+          </a:p>
+        </p:txBody>
+      </p:sp>
+      <p:sp>
+        <p:nvSpPr>
+          <p:cNvPr id="12" name="Rectangle 11"/>
+          <p:cNvSpPr/>
+          <p:nvPr/>
+        </p:nvSpPr>
+        <p:spPr>
+          <a:xfrm>
+            <a:off x="4572000" y="4114800"/>
+            <a:ext cx="137160" cy="1051560"/>
+          </a:xfrm>
+          <a:prstGeom prst="rect">
+            <a:avLst/>
+          </a:prstGeom>
+          <a:solidFill>
+            <a:srgbClr val="10B981"/>
+          </a:solidFill>
+          <a:ln>
+            <a:noFill/>
+          </a:ln>
+        </p:spPr>
+        <p:style>
+          <a:lnRef idx="1">
+            <a:schemeClr val="accent1"/>
+          </a:lnRef>
+          <a:fillRef idx="3">
+            <a:schemeClr val="accent1"/>
+          </a:fillRef>
+          <a:effectRef idx="2">
+            <a:schemeClr val="accent1"/>
+          </a:effectRef>
+          <a:fontRef idx="minor">
+            <a:schemeClr val="lt1"/>
+          </a:fontRef>
+        </p:style>
+        <p:txBody>
+          <a:bodyPr rtlCol="0" anchor="ctr"/>
+          <a:lstStyle/>
+          <a:p>
+            <a:pPr algn="ctr"/>
+          </a:p>
+        </p:txBody>
+      </p:sp>
+      <p:sp>
+        <p:nvSpPr>
+          <p:cNvPr id="13" name="Rounded Rectangle 12"/>
+          <p:cNvSpPr/>
+          <p:nvPr/>
+        </p:nvSpPr>
+        <p:spPr>
+          <a:xfrm>
+            <a:off x="4572000" y="5303520"/>
+            <a:ext cx="7040880" cy="1051560"/>
+          </a:xfrm>
+          <a:prstGeom prst="roundRect">
+            <a:avLst/>
+          </a:prstGeom>
+          <a:solidFill>
+            <a:srgbClr val="FFFFFF"/>
+          </a:solidFill>
+          <a:ln w="19050">
+            <a:solidFill>
+              <a:srgbClr val="E2E8F0"/>
+            </a:solidFill>
+          </a:ln>
+        </p:spPr>
+        <p:style>
+          <a:lnRef idx="1">
+            <a:schemeClr val="accent1"/>
+          </a:lnRef>
+          <a:fillRef idx="3">
+            <a:schemeClr val="accent1"/>
+          </a:fillRef>
+          <a:effectRef idx="2">
+            <a:schemeClr val="accent1"/>
+          </a:effectRef>
+          <a:fontRef idx="minor">
+            <a:schemeClr val="lt1"/>
+          </a:fontRef>
+        </p:style>
+        <p:txBody>
+          <a:bodyPr rtlCol="0" anchor="ctr" wrap="square"/>
+          <a:lstStyle/>
+          <a:p>
+            <a:pPr algn="ctr">
+              <a:defRPr sz="1300" b="1">
+                <a:solidFill>
+                  <a:srgbClr val="10B981"/>
+                </a:solidFill>
+              </a:defRPr>
+            </a:pPr>
+            <a:r>
+              <a:t>Checkpoint 4: Accounting Closed Flag Set</a:t>
+            </a:r>
+          </a:p>
+          <a:p>
+            <a:pPr>
+              <a:spcBef>
+                <a:spcPts val="400"/>
+              </a:spcBef>
+              <a:defRPr sz="1100">
+                <a:solidFill>
+                  <a:srgbClr val="1E293B"/>
+                </a:solidFill>
+              </a:defRPr>
+            </a:pPr>
+            <a:r>
+              <a:t>Financial audit locked by Accounting Administrator (AccountingClosed == true).</a:t>
+            </a:r>
+          </a:p>
+        </p:txBody>
+      </p:sp>
+      <p:sp>
+        <p:nvSpPr>
+          <p:cNvPr id="14" name="Rectangle 13"/>
+          <p:cNvSpPr/>
+          <p:nvPr/>
+        </p:nvSpPr>
+        <p:spPr>
+          <a:xfrm>
+            <a:off x="4572000" y="5303520"/>
+            <a:ext cx="137160" cy="1051560"/>
+          </a:xfrm>
+          <a:prstGeom prst="rect">
+            <a:avLst/>
+          </a:prstGeom>
+          <a:solidFill>
+            <a:srgbClr val="10B981"/>
+          </a:solidFill>
+          <a:ln>
+            <a:noFill/>
+          </a:ln>
+        </p:spPr>
+        <p:style>
+          <a:lnRef idx="1">
+            <a:schemeClr val="accent1"/>
+          </a:lnRef>
+          <a:fillRef idx="3">
+            <a:schemeClr val="accent1"/>
+          </a:fillRef>
+          <a:effectRef idx="2">
+            <a:schemeClr val="accent1"/>
+          </a:effectRef>
+          <a:fontRef idx="minor">
+            <a:schemeClr val="lt1"/>
+          </a:fontRef>
+        </p:style>
+        <p:txBody>
+          <a:bodyPr rtlCol="0" anchor="ctr"/>
+          <a:lstStyle/>
+          <a:p>
+            <a:pPr algn="ctr"/>
+          </a:p>
+        </p:txBody>
+      </p:sp>
+    </p:spTree>
+  </p:cSld>
+  <p:clrMapOvr>
+    <a:masterClrMapping/>
+  </p:clrMapOvr>
+</p:sld>
+</file>
+
+<file path=ppt/slides/slide6.xml><?xml version="1.0" encoding="utf-8"?>
+<p:sld xmlns:a="http://schemas.openxmlformats.org/drawingml/2006/main" xmlns:p="http://schemas.openxmlformats.org/presentationml/2006/main" xmlns:r="http://schemas.openxmlformats.org/officeDocument/2006/relationships">
+  <p:cSld>
+    <p:spTree>
+      <p:nvGrpSpPr>
+        <p:cNvPr id="1" name=""/>
+        <p:cNvGrpSpPr/>
+        <p:nvPr/>
+      </p:nvGrpSpPr>
+      <p:grpSpPr/>
+      <p:sp>
+        <p:nvSpPr>
+          <p:cNvPr id="2" name="Rectangle 1"/>
+          <p:cNvSpPr/>
+          <p:nvPr/>
+        </p:nvSpPr>
+        <p:spPr>
+          <a:xfrm>
+            <a:off x="0" y="0"/>
+            <a:ext cx="12191695" cy="1005840"/>
+          </a:xfrm>
+          <a:prstGeom prst="rect">
+            <a:avLst/>
+          </a:prstGeom>
+          <a:solidFill>
+            <a:srgbClr val="0F172A"/>
+          </a:solidFill>
+          <a:ln>
+            <a:noFill/>
+          </a:ln>
+        </p:spPr>
+        <p:style>
+          <a:lnRef idx="1">
+            <a:schemeClr val="accent1"/>
+          </a:lnRef>
+          <a:fillRef idx="3">
+            <a:schemeClr val="accent1"/>
+          </a:fillRef>
+          <a:effectRef idx="2">
+            <a:schemeClr val="accent1"/>
+          </a:effectRef>
+          <a:fontRef idx="minor">
+            <a:schemeClr val="lt1"/>
+          </a:fontRef>
+        </p:style>
+        <p:txBody>
+          <a:bodyPr rtlCol="0" anchor="ctr"/>
+          <a:lstStyle/>
+          <a:p>
+            <a:pPr algn="ctr"/>
+          </a:p>
+        </p:txBody>
+      </p:sp>
+      <p:sp>
+        <p:nvSpPr>
+          <p:cNvPr id="3" name="TextBox 2"/>
+          <p:cNvSpPr txBox="1"/>
+          <p:nvPr/>
+        </p:nvSpPr>
+        <p:spPr>
+          <a:xfrm>
+            <a:off x="548640" y="137160"/>
+            <a:ext cx="8686800" cy="731520"/>
+          </a:xfrm>
+          <a:prstGeom prst="rect">
+            <a:avLst/>
+          </a:prstGeom>
+          <a:noFill/>
+        </p:spPr>
+        <p:txBody>
+          <a:bodyPr wrap="square">
+            <a:spAutoFit/>
+          </a:bodyPr>
+          <a:lstStyle/>
+          <a:p>
+            <a:pPr>
+              <a:defRPr sz="2200" b="1">
+                <a:solidFill>
+                  <a:srgbClr val="FFFFFF"/>
+                </a:solidFill>
+              </a:defRPr>
+            </a:pPr>
+            <a:r>
+              <a:t>Transition Gate 5: Any Status ➔ Cancelled</a:t>
+            </a:r>
+          </a:p>
+        </p:txBody>
+      </p:sp>
+      <p:sp>
+        <p:nvSpPr>
+          <p:cNvPr id="4" name="Rounded Rectangle 3"/>
+          <p:cNvSpPr/>
+          <p:nvPr/>
+        </p:nvSpPr>
+        <p:spPr>
+          <a:xfrm>
+            <a:off x="9144000" y="274320"/>
+            <a:ext cx="2468880" cy="411480"/>
+          </a:xfrm>
+          <a:prstGeom prst="roundRect">
+            <a:avLst/>
+          </a:prstGeom>
+          <a:solidFill>
+            <a:srgbClr val="2563EB"/>
+          </a:solidFill>
+          <a:ln>
+            <a:noFill/>
+          </a:ln>
+        </p:spPr>
+        <p:style>
+          <a:lnRef idx="1">
+            <a:schemeClr val="accent1"/>
+          </a:lnRef>
+          <a:fillRef idx="3">
+            <a:schemeClr val="accent1"/>
+          </a:fillRef>
+          <a:effectRef idx="2">
+            <a:schemeClr val="accent1"/>
+          </a:effectRef>
+          <a:fontRef idx="minor">
+            <a:schemeClr val="lt1"/>
+          </a:fontRef>
+        </p:style>
+        <p:txBody>
+          <a:bodyPr rtlCol="0" anchor="ctr"/>
+          <a:lstStyle/>
+          <a:p>
+            <a:pPr algn="ctr">
+              <a:defRPr sz="1100" b="1">
+                <a:solidFill>
+                  <a:srgbClr val="FFFFFF"/>
+                </a:solidFill>
+              </a:defRPr>
+            </a:pPr>
+            <a:r>
+              <a:t>GATE 5 (ORDER 1-4➔6)</a:t>
+            </a:r>
+          </a:p>
+        </p:txBody>
+      </p:sp>
+      <p:sp>
+        <p:nvSpPr>
+          <p:cNvPr id="5" name="Rounded Rectangle 4"/>
+          <p:cNvSpPr/>
+          <p:nvPr/>
+        </p:nvSpPr>
+        <p:spPr>
+          <a:xfrm>
+            <a:off x="548640" y="1280160"/>
+            <a:ext cx="3840480" cy="5120640"/>
+          </a:xfrm>
+          <a:prstGeom prst="roundRect">
+            <a:avLst/>
+          </a:prstGeom>
+          <a:solidFill>
+            <a:srgbClr val="F8FAFC"/>
+          </a:solidFill>
+          <a:ln w="25400">
+            <a:solidFill>
+              <a:srgbClr val="F43F5E"/>
+            </a:solidFill>
+          </a:ln>
+        </p:spPr>
+        <p:style>
+          <a:lnRef idx="1">
+            <a:schemeClr val="accent1"/>
+          </a:lnRef>
+          <a:fillRef idx="3">
+            <a:schemeClr val="accent1"/>
+          </a:fillRef>
+          <a:effectRef idx="2">
+            <a:schemeClr val="accent1"/>
+          </a:effectRef>
+          <a:fontRef idx="minor">
+            <a:schemeClr val="lt1"/>
+          </a:fontRef>
+        </p:style>
+        <p:txBody>
+          <a:bodyPr rtlCol="0" anchor="ctr" wrap="square"/>
+          <a:lstStyle/>
+          <a:p>
+            <a:pPr algn="ctr">
+              <a:defRPr sz="1200" b="1">
+                <a:solidFill>
+                  <a:srgbClr val="64748B"/>
+                </a:solidFill>
+              </a:defRPr>
+            </a:pPr>
+            <a:r>
+              <a:t>FORWARD TRANSITION</a:t>
+            </a:r>
+          </a:p>
+          <a:p>
+            <a:pPr>
+              <a:spcBef>
+                <a:spcPts val="600"/>
+              </a:spcBef>
+              <a:defRPr sz="1800" b="1">
+                <a:solidFill>
+                  <a:srgbClr val="F43F5E"/>
+                </a:solidFill>
+              </a:defRPr>
+            </a:pPr>
+            <a:r>
+              <a:t>Active Status  ➔  Cancelled</a:t>
+            </a:r>
+          </a:p>
+          <a:p>
+            <a:pPr>
+              <a:spcBef>
+                <a:spcPts val="1600"/>
+              </a:spcBef>
+              <a:defRPr sz="1300" b="1">
+                <a:solidFill>
+                  <a:srgbClr val="1E293B"/>
+                </a:solidFill>
+              </a:defRPr>
+            </a:pPr>
+            <a:r>
+              <a:t>Business Meaning &amp; Impact:</a:t>
+            </a:r>
+          </a:p>
+          <a:p>
+            <a:pPr>
+              <a:spcBef>
+                <a:spcPts val="600"/>
+              </a:spcBef>
+              <a:defRPr sz="1100">
+                <a:solidFill>
+                  <a:srgbClr val="64748B"/>
+                </a:solidFill>
+              </a:defRPr>
+            </a:pPr>
+            <a:r>
+              <a:t>Safely handles cancelled departures, resolves supplier penalties, and prevents invalid revenue billing.</a:t>
+            </a:r>
+          </a:p>
+          <a:p>
+            <a:pPr>
+              <a:spcBef>
+                <a:spcPts val="1600"/>
+              </a:spcBef>
+              <a:defRPr sz="1300" b="1">
+                <a:solidFill>
+                  <a:srgbClr val="1E293B"/>
+                </a:solidFill>
+              </a:defRPr>
+            </a:pPr>
+            <a:r>
+              <a:t>Automated System Checks:</a:t>
+            </a:r>
+          </a:p>
+          <a:p>
+            <a:pPr>
+              <a:spcBef>
+                <a:spcPts val="400"/>
+              </a:spcBef>
+              <a:defRPr sz="1100">
+                <a:solidFill>
+                  <a:srgbClr val="F43F5E"/>
+                </a:solidFill>
+              </a:defRPr>
+            </a:pPr>
+            <a:r>
+              <a:t>• CancellationReason != null</a:t>
+            </a:r>
+          </a:p>
+          <a:p>
+            <a:pPr>
+              <a:spcBef>
+                <a:spcPts val="400"/>
+              </a:spcBef>
+              <a:defRPr sz="1100">
+                <a:solidFill>
+                  <a:srgbClr val="F43F5E"/>
+                </a:solidFill>
+              </a:defRPr>
+            </a:pPr>
+            <a:r>
+              <a:t>• SupplierPenaltiesCalculated == true</a:t>
+            </a:r>
+          </a:p>
+          <a:p>
+            <a:pPr>
+              <a:spcBef>
+                <a:spcPts val="400"/>
+              </a:spcBef>
+              <a:defRPr sz="1100">
+                <a:solidFill>
+                  <a:srgbClr val="F43F5E"/>
+                </a:solidFill>
+              </a:defRPr>
+            </a:pPr>
+            <a:r>
+              <a:t>• CreditNoteGenerated == true</a:t>
+            </a:r>
+          </a:p>
+        </p:txBody>
+      </p:sp>
+      <p:sp>
+        <p:nvSpPr>
+          <p:cNvPr id="6" name="TextBox 5"/>
+          <p:cNvSpPr txBox="1"/>
+          <p:nvPr/>
+        </p:nvSpPr>
+        <p:spPr>
+          <a:xfrm>
+            <a:off x="4572000" y="1188720"/>
+            <a:ext cx="7040880" cy="5212080"/>
+          </a:xfrm>
+          <a:prstGeom prst="rect">
+            <a:avLst/>
+          </a:prstGeom>
+          <a:noFill/>
+        </p:spPr>
+        <p:txBody>
+          <a:bodyPr wrap="square">
+            <a:spAutoFit/>
+          </a:bodyPr>
+          <a:lstStyle/>
+          <a:p>
+            <a:pPr>
+              <a:defRPr sz="1500" b="1">
+                <a:solidFill>
+                  <a:srgbClr val="1E293B"/>
+                </a:solidFill>
+              </a:defRPr>
+            </a:pPr>
+            <a:r>
+              <a:t>Mandatory Transition Checkpoints (100% Pass Required):</a:t>
+            </a:r>
+          </a:p>
+        </p:txBody>
+      </p:sp>
+      <p:sp>
+        <p:nvSpPr>
+          <p:cNvPr id="7" name="Rounded Rectangle 6"/>
+          <p:cNvSpPr/>
+          <p:nvPr/>
+        </p:nvSpPr>
+        <p:spPr>
+          <a:xfrm>
+            <a:off x="4572000" y="1737360"/>
+            <a:ext cx="7040880" cy="1051560"/>
+          </a:xfrm>
+          <a:prstGeom prst="roundRect">
+            <a:avLst/>
+          </a:prstGeom>
+          <a:solidFill>
+            <a:srgbClr val="FFFFFF"/>
+          </a:solidFill>
+          <a:ln w="19050">
+            <a:solidFill>
+              <a:srgbClr val="E2E8F0"/>
+            </a:solidFill>
+          </a:ln>
+        </p:spPr>
+        <p:style>
+          <a:lnRef idx="1">
+            <a:schemeClr val="accent1"/>
+          </a:lnRef>
+          <a:fillRef idx="3">
+            <a:schemeClr val="accent1"/>
+          </a:fillRef>
+          <a:effectRef idx="2">
+            <a:schemeClr val="accent1"/>
+          </a:effectRef>
+          <a:fontRef idx="minor">
+            <a:schemeClr val="lt1"/>
+          </a:fontRef>
+        </p:style>
+        <p:txBody>
+          <a:bodyPr rtlCol="0" anchor="ctr" wrap="square"/>
+          <a:lstStyle/>
+          <a:p>
+            <a:pPr algn="ctr">
+              <a:defRPr sz="1300" b="1">
+                <a:solidFill>
+                  <a:srgbClr val="F43F5E"/>
+                </a:solidFill>
+              </a:defRPr>
+            </a:pPr>
+            <a:r>
+              <a:t>Checkpoint 1: Cancellation Reason Logged</a:t>
+            </a:r>
+          </a:p>
+          <a:p>
+            <a:pPr>
+              <a:spcBef>
+                <a:spcPts val="400"/>
+              </a:spcBef>
+              <a:defRPr sz="1100">
+                <a:solidFill>
+                  <a:srgbClr val="1E293B"/>
+                </a:solidFill>
+              </a:defRPr>
+            </a:pPr>
+            <a:r>
+              <a:t>Formal cancellation reason recorded in AuditLogs with user timestamp &amp; administrator approval.</a:t>
+            </a:r>
+          </a:p>
+        </p:txBody>
+      </p:sp>
+      <p:sp>
+        <p:nvSpPr>
+          <p:cNvPr id="8" name="Rectangle 7"/>
+          <p:cNvSpPr/>
+          <p:nvPr/>
+        </p:nvSpPr>
+        <p:spPr>
+          <a:xfrm>
+            <a:off x="4572000" y="1737360"/>
+            <a:ext cx="137160" cy="1051560"/>
+          </a:xfrm>
+          <a:prstGeom prst="rect">
+            <a:avLst/>
+          </a:prstGeom>
+          <a:solidFill>
+            <a:srgbClr val="F43F5E"/>
+          </a:solidFill>
+          <a:ln>
+            <a:noFill/>
+          </a:ln>
+        </p:spPr>
+        <p:style>
+          <a:lnRef idx="1">
+            <a:schemeClr val="accent1"/>
+          </a:lnRef>
+          <a:fillRef idx="3">
+            <a:schemeClr val="accent1"/>
+          </a:fillRef>
+          <a:effectRef idx="2">
+            <a:schemeClr val="accent1"/>
+          </a:effectRef>
+          <a:fontRef idx="minor">
+            <a:schemeClr val="lt1"/>
+          </a:fontRef>
+        </p:style>
+        <p:txBody>
+          <a:bodyPr rtlCol="0" anchor="ctr"/>
+          <a:lstStyle/>
+          <a:p>
+            <a:pPr algn="ctr"/>
+          </a:p>
+        </p:txBody>
+      </p:sp>
+      <p:sp>
+        <p:nvSpPr>
+          <p:cNvPr id="9" name="Rounded Rectangle 8"/>
+          <p:cNvSpPr/>
+          <p:nvPr/>
+        </p:nvSpPr>
+        <p:spPr>
+          <a:xfrm>
+            <a:off x="4572000" y="2926080"/>
+            <a:ext cx="7040880" cy="1051560"/>
+          </a:xfrm>
+          <a:prstGeom prst="roundRect">
+            <a:avLst/>
+          </a:prstGeom>
+          <a:solidFill>
+            <a:srgbClr val="FFFFFF"/>
+          </a:solidFill>
+          <a:ln w="19050">
+            <a:solidFill>
+              <a:srgbClr val="E2E8F0"/>
+            </a:solidFill>
+          </a:ln>
+        </p:spPr>
+        <p:style>
+          <a:lnRef idx="1">
+            <a:schemeClr val="accent1"/>
+          </a:lnRef>
+          <a:fillRef idx="3">
+            <a:schemeClr val="accent1"/>
+          </a:fillRef>
+          <a:effectRef idx="2">
+            <a:schemeClr val="accent1"/>
+          </a:effectRef>
+          <a:fontRef idx="minor">
+            <a:schemeClr val="lt1"/>
+          </a:fontRef>
+        </p:style>
+        <p:txBody>
+          <a:bodyPr rtlCol="0" anchor="ctr" wrap="square"/>
+          <a:lstStyle/>
+          <a:p>
+            <a:pPr algn="ctr">
+              <a:defRPr sz="1300" b="1">
+                <a:solidFill>
+                  <a:srgbClr val="F43F5E"/>
+                </a:solidFill>
+              </a:defRPr>
+            </a:pPr>
+            <a:r>
+              <a:t>Checkpoint 2: Supplier Cancellation Policy Check</a:t>
+            </a:r>
+          </a:p>
+          <a:p>
+            <a:pPr>
+              <a:spcBef>
+                <a:spcPts val="400"/>
+              </a:spcBef>
+              <a:defRPr sz="1100">
+                <a:solidFill>
+                  <a:srgbClr val="1E293B"/>
+                </a:solidFill>
+              </a:defRPr>
+            </a:pPr>
+            <a:r>
+              <a:t>Hotel &amp; transport cancellation penalty fees computed according to contractual SLAs.</a:t>
+            </a:r>
+          </a:p>
+        </p:txBody>
+      </p:sp>
+      <p:sp>
+        <p:nvSpPr>
+          <p:cNvPr id="10" name="Rectangle 9"/>
+          <p:cNvSpPr/>
+          <p:nvPr/>
+        </p:nvSpPr>
+        <p:spPr>
+          <a:xfrm>
+            <a:off x="4572000" y="2926080"/>
+            <a:ext cx="137160" cy="1051560"/>
+          </a:xfrm>
+          <a:prstGeom prst="rect">
+            <a:avLst/>
+          </a:prstGeom>
+          <a:solidFill>
+            <a:srgbClr val="F43F5E"/>
+          </a:solidFill>
+          <a:ln>
+            <a:noFill/>
+          </a:ln>
+        </p:spPr>
+        <p:style>
+          <a:lnRef idx="1">
+            <a:schemeClr val="accent1"/>
+          </a:lnRef>
+          <a:fillRef idx="3">
+            <a:schemeClr val="accent1"/>
+          </a:fillRef>
+          <a:effectRef idx="2">
+            <a:schemeClr val="accent1"/>
+          </a:effectRef>
+          <a:fontRef idx="minor">
+            <a:schemeClr val="lt1"/>
+          </a:fontRef>
+        </p:style>
+        <p:txBody>
+          <a:bodyPr rtlCol="0" anchor="ctr"/>
+          <a:lstStyle/>
+          <a:p>
+            <a:pPr algn="ctr"/>
+          </a:p>
+        </p:txBody>
+      </p:sp>
+      <p:sp>
+        <p:nvSpPr>
+          <p:cNvPr id="11" name="Rounded Rectangle 10"/>
+          <p:cNvSpPr/>
+          <p:nvPr/>
+        </p:nvSpPr>
+        <p:spPr>
+          <a:xfrm>
+            <a:off x="4572000" y="4114800"/>
+            <a:ext cx="7040880" cy="1051560"/>
+          </a:xfrm>
+          <a:prstGeom prst="roundRect">
+            <a:avLst/>
+          </a:prstGeom>
+          <a:solidFill>
+            <a:srgbClr val="FFFFFF"/>
+          </a:solidFill>
+          <a:ln w="19050">
+            <a:solidFill>
+              <a:srgbClr val="E2E8F0"/>
+            </a:solidFill>
+          </a:ln>
+        </p:spPr>
+        <p:style>
+          <a:lnRef idx="1">
+            <a:schemeClr val="accent1"/>
+          </a:lnRef>
+          <a:fillRef idx="3">
+            <a:schemeClr val="accent1"/>
+          </a:fillRef>
+          <a:effectRef idx="2">
+            <a:schemeClr val="accent1"/>
+          </a:effectRef>
+          <a:fontRef idx="minor">
+            <a:schemeClr val="lt1"/>
+          </a:fontRef>
+        </p:style>
+        <p:txBody>
+          <a:bodyPr rtlCol="0" anchor="ctr" wrap="square"/>
+          <a:lstStyle/>
+          <a:p>
+            <a:pPr algn="ctr">
+              <a:defRPr sz="1300" b="1">
+                <a:solidFill>
+                  <a:srgbClr val="F43F5E"/>
+                </a:solidFill>
+              </a:defRPr>
+            </a:pPr>
+            <a:r>
+              <a:t>Checkpoint 3: Client Deposit Refund / Credit Note</a:t>
+            </a:r>
+          </a:p>
+          <a:p>
+            <a:pPr>
+              <a:spcBef>
+                <a:spcPts val="400"/>
+              </a:spcBef>
+              <a:defRPr sz="1100">
+                <a:solidFill>
+                  <a:srgbClr val="1E293B"/>
+                </a:solidFill>
+              </a:defRPr>
+            </a:pPr>
+            <a:r>
+              <a:t>Client refund balance or credit note generated in Accounting ledger.</a:t>
+            </a:r>
+          </a:p>
+        </p:txBody>
+      </p:sp>
+      <p:sp>
+        <p:nvSpPr>
+          <p:cNvPr id="12" name="Rectangle 11"/>
+          <p:cNvSpPr/>
+          <p:nvPr/>
+        </p:nvSpPr>
+        <p:spPr>
+          <a:xfrm>
+            <a:off x="4572000" y="4114800"/>
+            <a:ext cx="137160" cy="1051560"/>
+          </a:xfrm>
+          <a:prstGeom prst="rect">
+            <a:avLst/>
+          </a:prstGeom>
+          <a:solidFill>
+            <a:srgbClr val="F43F5E"/>
+          </a:solidFill>
+          <a:ln>
+            <a:noFill/>
+          </a:ln>
+        </p:spPr>
+        <p:style>
+          <a:lnRef idx="1">
+            <a:schemeClr val="accent1"/>
+          </a:lnRef>
+          <a:fillRef idx="3">
+            <a:schemeClr val="accent1"/>
+          </a:fillRef>
+          <a:effectRef idx="2">
+            <a:schemeClr val="accent1"/>
+          </a:effectRef>
+          <a:fontRef idx="minor">
+            <a:schemeClr val="lt1"/>
+          </a:fontRef>
+        </p:style>
+        <p:txBody>
+          <a:bodyPr rtlCol="0" anchor="ctr"/>
+          <a:lstStyle/>
+          <a:p>
+            <a:pPr algn="ctr"/>
+          </a:p>
+        </p:txBody>
+      </p:sp>
+    </p:spTree>
+  </p:cSld>
+  <p:clrMapOvr>
+    <a:masterClrMapping/>
+  </p:clrMapOvr>
+</p:sld>
+</file>
+
+<file path=ppt/slides/slide7.xml><?xml version="1.0" encoding="utf-8"?>
+<p:sld xmlns:a="http://schemas.openxmlformats.org/drawingml/2006/main" xmlns:p="http://schemas.openxmlformats.org/presentationml/2006/main" xmlns:r="http://schemas.openxmlformats.org/officeDocument/2006/relationships">
+  <p:cSld>
+    <p:spTree>
+      <p:nvGrpSpPr>
+        <p:cNvPr id="1" name=""/>
+        <p:cNvGrpSpPr/>
+        <p:nvPr/>
+      </p:nvGrpSpPr>
+      <p:grpSpPr/>
+      <p:sp>
+        <p:nvSpPr>
+          <p:cNvPr id="2" name="Rectangle 1"/>
+          <p:cNvSpPr/>
+          <p:nvPr/>
+        </p:nvSpPr>
+        <p:spPr>
+          <a:xfrm>
+            <a:off x="0" y="0"/>
+            <a:ext cx="12191695" cy="1005840"/>
+          </a:xfrm>
+          <a:prstGeom prst="rect">
+            <a:avLst/>
+          </a:prstGeom>
+          <a:solidFill>
+            <a:srgbClr val="0F172A"/>
+          </a:solidFill>
+          <a:ln>
+            <a:noFill/>
+          </a:ln>
+        </p:spPr>
+        <p:style>
+          <a:lnRef idx="1">
+            <a:schemeClr val="accent1"/>
+          </a:lnRef>
+          <a:fillRef idx="3">
+            <a:schemeClr val="accent1"/>
+          </a:fillRef>
+          <a:effectRef idx="2">
+            <a:schemeClr val="accent1"/>
+          </a:effectRef>
+          <a:fontRef idx="minor">
+            <a:schemeClr val="lt1"/>
+          </a:fontRef>
+        </p:style>
+        <p:txBody>
+          <a:bodyPr rtlCol="0" anchor="ctr"/>
+          <a:lstStyle/>
+          <a:p>
+            <a:pPr algn="ctr"/>
+          </a:p>
+        </p:txBody>
+      </p:sp>
+      <p:sp>
+        <p:nvSpPr>
+          <p:cNvPr id="3" name="TextBox 2"/>
+          <p:cNvSpPr txBox="1"/>
+          <p:nvPr/>
+        </p:nvSpPr>
+        <p:spPr>
+          <a:xfrm>
+            <a:off x="548640" y="137160"/>
+            <a:ext cx="8686800" cy="731520"/>
+          </a:xfrm>
+          <a:prstGeom prst="rect">
+            <a:avLst/>
+          </a:prstGeom>
+          <a:noFill/>
+        </p:spPr>
+        <p:txBody>
+          <a:bodyPr wrap="square">
+            <a:spAutoFit/>
+          </a:bodyPr>
+          <a:lstStyle/>
+          <a:p>
+            <a:pPr>
+              <a:defRPr sz="2200" b="1">
+                <a:solidFill>
+                  <a:srgbClr val="FFFFFF"/>
+                </a:solidFill>
+              </a:defRPr>
+            </a:pPr>
+            <a:r>
+              <a:t>Automated Time-Window Warning System</a:t>
+            </a:r>
+          </a:p>
+        </p:txBody>
+      </p:sp>
+      <p:sp>
+        <p:nvSpPr>
+          <p:cNvPr id="4" name="Rounded Rectangle 3"/>
+          <p:cNvSpPr/>
+          <p:nvPr/>
+        </p:nvSpPr>
+        <p:spPr>
+          <a:xfrm>
+            <a:off x="9144000" y="274320"/>
+            <a:ext cx="2468880" cy="411480"/>
+          </a:xfrm>
+          <a:prstGeom prst="roundRect">
+            <a:avLst/>
+          </a:prstGeom>
+          <a:solidFill>
+            <a:srgbClr val="2563EB"/>
+          </a:solidFill>
+          <a:ln>
+            <a:noFill/>
+          </a:ln>
+        </p:spPr>
+        <p:style>
+          <a:lnRef idx="1">
+            <a:schemeClr val="accent1"/>
+          </a:lnRef>
+          <a:fillRef idx="3">
+            <a:schemeClr val="accent1"/>
+          </a:fillRef>
+          <a:effectRef idx="2">
+            <a:schemeClr val="accent1"/>
+          </a:effectRef>
+          <a:fontRef idx="minor">
+            <a:schemeClr val="lt1"/>
+          </a:fontRef>
+        </p:style>
+        <p:txBody>
+          <a:bodyPr rtlCol="0" anchor="ctr"/>
+          <a:lstStyle/>
+          <a:p>
+            <a:pPr algn="ctr">
+              <a:defRPr sz="1100" b="1">
+                <a:solidFill>
+                  <a:srgbClr val="FFFFFF"/>
+                </a:solidFill>
+              </a:defRPr>
+            </a:pPr>
+            <a:r>
+              <a:t>SLA WARNINGS</a:t>
+            </a:r>
+          </a:p>
+        </p:txBody>
+      </p:sp>
+      <p:sp>
+        <p:nvSpPr>
+          <p:cNvPr id="5" name="Rounded Rectangle 4"/>
           <p:cNvSpPr/>
           <p:nvPr/>
         </p:nvSpPr>
@@ -4865,7 +7304,7 @@
       </p:sp>
       <p:sp>
         <p:nvSpPr>
-          <p:cNvPr id="7" name="Rounded Rectangle 6"/>
+          <p:cNvPr id="6" name="Rounded Rectangle 5"/>
           <p:cNvSpPr/>
           <p:nvPr/>
         </p:nvSpPr>
@@ -4934,7 +7373,7 @@
       </p:sp>
       <p:sp>
         <p:nvSpPr>
-          <p:cNvPr id="8" name="Rounded Rectangle 7"/>
+          <p:cNvPr id="7" name="Rounded Rectangle 6"/>
           <p:cNvSpPr/>
           <p:nvPr/>
         </p:nvSpPr>
@@ -5003,7 +7442,7 @@
       </p:sp>
       <p:sp>
         <p:nvSpPr>
-          <p:cNvPr id="9" name="Rounded Rectangle 8"/>
+          <p:cNvPr id="8" name="Rounded Rectangle 7"/>
           <p:cNvSpPr/>
           <p:nvPr/>
         </p:nvSpPr>

</xml_diff>